<commit_message>
docs: update observability portal executive deck to version 3
</commit_message>
<xml_diff>
--- a/docs/ui-ux-design/diagrams/observability-portal-exec-deck-v3.pptx
+++ b/docs/ui-ux-design/diagrams/observability-portal-exec-deck-v3.pptx
@@ -3251,13 +3251,22 @@
               </a:spcAft>
             </a:pPr>
             <a:r>
+              <a:rPr sz="1200" b="1">
+                <a:solidFill>
+                  <a:srgbClr val="2E74B5"/>
+                </a:solidFill>
+                <a:latin typeface="Segoe UI"/>
+              </a:rPr>
+              <a:t>An Observability Transformation</a:t>
+            </a:r>
+            <a:r>
               <a:rPr sz="1150" b="0">
                 <a:solidFill>
                   <a:srgbClr val="7A808A"/>
                 </a:solidFill>
                 <a:latin typeface="Segoe UI"/>
               </a:rPr>
-              <a:t>A self-service portal, built on open-source Backstage, that turns every monitoring request into a governed, automated pipeline — users see services, never tools.</a:t>
+              <a:t> — not a tool rollout: one self-service portal, built on open-source Backstage, that turns every monitoring request into a governed, automated pipeline. Users see services, never tools.</a:t>
             </a:r>
           </a:p>
         </p:txBody>
@@ -12245,8 +12254,8 @@
         </p:nvSpPr>
         <p:spPr>
           <a:xfrm>
-            <a:off x="548640" y="640080"/>
-            <a:ext cx="11064240" cy="502920"/>
+            <a:off x="548640" y="621792"/>
+            <a:ext cx="11064240" cy="475488"/>
           </a:xfrm>
           <a:prstGeom prst="rect">
             <a:avLst/>
@@ -12265,7 +12274,7 @@
               </a:spcAft>
             </a:pPr>
             <a:r>
-              <a:rPr sz="2400" b="1">
+              <a:rPr sz="2200" b="1">
                 <a:solidFill>
                   <a:srgbClr val="1B2A41"/>
                 </a:solidFill>
@@ -12284,7 +12293,7 @@
         </p:nvSpPr>
         <p:spPr>
           <a:xfrm>
-            <a:off x="566928" y="1207008"/>
+            <a:off x="566928" y="1152144"/>
             <a:ext cx="914400" cy="32004"/>
           </a:xfrm>
           <a:prstGeom prst="rect">
@@ -12322,52 +12331,13 @@
       </p:sp>
       <p:sp>
         <p:nvSpPr>
-          <p:cNvPr id="5" name="TextBox 4"/>
-          <p:cNvSpPr txBox="1"/>
-          <p:nvPr/>
-        </p:nvSpPr>
-        <p:spPr>
-          <a:xfrm>
-            <a:off x="548640" y="1316736"/>
-            <a:ext cx="11064240" cy="292608"/>
-          </a:xfrm>
-          <a:prstGeom prst="rect">
-            <a:avLst/>
-          </a:prstGeom>
-          <a:noFill/>
-        </p:spPr>
-        <p:txBody>
-          <a:bodyPr wrap="square" anchor="t" lIns="0" rIns="0" tIns="0" bIns="0">
-            <a:spAutoFit/>
-          </a:bodyPr>
-          <a:lstStyle/>
-          <a:p>
-            <a:pPr algn="l">
-              <a:spcAft>
-                <a:spcPts val="400"/>
-              </a:spcAft>
-            </a:pPr>
-            <a:r>
-              <a:rPr sz="1100" b="0">
-                <a:solidFill>
-                  <a:srgbClr val="7A808A"/>
-                </a:solidFill>
-                <a:latin typeface="Segoe UI"/>
-              </a:rPr>
-              <a:t>Eleven services, one design language — every one already designed and demoable in the portal prototype. The roadmap is activation order, not invention.</a:t>
-            </a:r>
-          </a:p>
-        </p:txBody>
-      </p:sp>
-      <p:sp>
-        <p:nvSpPr>
-          <p:cNvPr id="6" name="Rectangle 5"/>
+          <p:cNvPr id="5" name="Rectangle 4"/>
           <p:cNvSpPr/>
           <p:nvPr/>
         </p:nvSpPr>
         <p:spPr>
           <a:xfrm>
-            <a:off x="566928" y="2212848"/>
+            <a:off x="566928" y="1700784"/>
             <a:ext cx="10607040" cy="20116"/>
           </a:xfrm>
           <a:prstGeom prst="rect">
@@ -12405,13 +12375,13 @@
       </p:sp>
       <p:sp>
         <p:nvSpPr>
-          <p:cNvPr id="7" name="Right Arrow 6"/>
+          <p:cNvPr id="6" name="Right Arrow 5"/>
           <p:cNvSpPr/>
           <p:nvPr/>
         </p:nvSpPr>
         <p:spPr>
           <a:xfrm>
-            <a:off x="11192256" y="2148840"/>
+            <a:off x="11192256" y="1636776"/>
             <a:ext cx="256032" cy="164592"/>
           </a:xfrm>
           <a:prstGeom prst="rightArrow">
@@ -12449,14 +12419,53 @@
       </p:sp>
       <p:sp>
         <p:nvSpPr>
+          <p:cNvPr id="7" name="TextBox 6"/>
+          <p:cNvSpPr txBox="1"/>
+          <p:nvPr/>
+        </p:nvSpPr>
+        <p:spPr>
+          <a:xfrm>
+            <a:off x="548640" y="1298448"/>
+            <a:ext cx="2121408" cy="219456"/>
+          </a:xfrm>
+          <a:prstGeom prst="rect">
+            <a:avLst/>
+          </a:prstGeom>
+          <a:noFill/>
+        </p:spPr>
+        <p:txBody>
+          <a:bodyPr wrap="square" anchor="t" lIns="0" rIns="0" tIns="0" bIns="0">
+            <a:spAutoFit/>
+          </a:bodyPr>
+          <a:lstStyle/>
+          <a:p>
+            <a:pPr algn="l">
+              <a:spcAft>
+                <a:spcPts val="400"/>
+              </a:spcAft>
+            </a:pPr>
+            <a:r>
+              <a:rPr sz="1100" b="1">
+                <a:solidFill>
+                  <a:srgbClr val="2E74B5"/>
+                </a:solidFill>
+                <a:latin typeface="Segoe UI"/>
+              </a:rPr>
+              <a:t>Q3 2026</a:t>
+            </a:r>
+          </a:p>
+        </p:txBody>
+      </p:sp>
+      <p:sp>
+        <p:nvSpPr>
           <p:cNvPr id="8" name="TextBox 7"/>
           <p:cNvSpPr txBox="1"/>
           <p:nvPr/>
         </p:nvSpPr>
         <p:spPr>
           <a:xfrm>
-            <a:off x="548640" y="1810512"/>
-            <a:ext cx="2121408" cy="237744"/>
+            <a:off x="548640" y="1508760"/>
+            <a:ext cx="2121408" cy="164592"/>
           </a:xfrm>
           <a:prstGeom prst="rect">
             <a:avLst/>
@@ -12475,45 +12484,6 @@
               </a:spcAft>
             </a:pPr>
             <a:r>
-              <a:rPr sz="1100" b="1">
-                <a:solidFill>
-                  <a:srgbClr val="2E74B5"/>
-                </a:solidFill>
-                <a:latin typeface="Segoe UI"/>
-              </a:rPr>
-              <a:t>Q3 2026</a:t>
-            </a:r>
-          </a:p>
-        </p:txBody>
-      </p:sp>
-      <p:sp>
-        <p:nvSpPr>
-          <p:cNvPr id="9" name="TextBox 8"/>
-          <p:cNvSpPr txBox="1"/>
-          <p:nvPr/>
-        </p:nvSpPr>
-        <p:spPr>
-          <a:xfrm>
-            <a:off x="548640" y="2029968"/>
-            <a:ext cx="2121408" cy="182880"/>
-          </a:xfrm>
-          <a:prstGeom prst="rect">
-            <a:avLst/>
-          </a:prstGeom>
-          <a:noFill/>
-        </p:spPr>
-        <p:txBody>
-          <a:bodyPr wrap="square" anchor="t" lIns="0" rIns="0" tIns="0" bIns="0">
-            <a:spAutoFit/>
-          </a:bodyPr>
-          <a:lstStyle/>
-          <a:p>
-            <a:pPr algn="l">
-              <a:spcAft>
-                <a:spcPts val="400"/>
-              </a:spcAft>
-            </a:pPr>
-            <a:r>
               <a:rPr sz="800" b="1">
                 <a:solidFill>
                   <a:srgbClr val="7A808A"/>
@@ -12527,13 +12497,13 @@
       </p:sp>
       <p:sp>
         <p:nvSpPr>
-          <p:cNvPr id="10" name="Rectangle 9"/>
+          <p:cNvPr id="9" name="Rectangle 8"/>
           <p:cNvSpPr/>
           <p:nvPr/>
         </p:nvSpPr>
         <p:spPr>
           <a:xfrm>
-            <a:off x="548640" y="2212848"/>
+            <a:off x="548640" y="1700784"/>
             <a:ext cx="457200" cy="25603"/>
           </a:xfrm>
           <a:prstGeom prst="rect">
@@ -12571,24 +12541,26 @@
       </p:sp>
       <p:sp>
         <p:nvSpPr>
-          <p:cNvPr id="11" name="Rectangle 10"/>
+          <p:cNvPr id="10" name="Rounded Rectangle 9"/>
           <p:cNvSpPr/>
           <p:nvPr/>
         </p:nvSpPr>
         <p:spPr>
           <a:xfrm>
-            <a:off x="548640" y="2395728"/>
-            <a:ext cx="2121408" cy="1060704"/>
-          </a:xfrm>
-          <a:prstGeom prst="rect">
-            <a:avLst/>
+            <a:off x="548640" y="1828800"/>
+            <a:ext cx="2121408" cy="1298448"/>
+          </a:xfrm>
+          <a:prstGeom prst="roundRect">
+            <a:avLst>
+              <a:gd name="adj" fmla="val 9000"/>
+            </a:avLst>
           </a:prstGeom>
           <a:solidFill>
             <a:srgbClr val="FFFFFF"/>
           </a:solidFill>
           <a:ln w="9525">
             <a:solidFill>
-              <a:srgbClr val="D8DCE1"/>
+              <a:srgbClr val="E1E6EF"/>
             </a:solidFill>
           </a:ln>
           <a:effectLst/>
@@ -12615,16 +12587,426 @@
           </a:p>
         </p:txBody>
       </p:sp>
-      <p:sp>
-        <p:nvSpPr>
-          <p:cNvPr id="12" name="Rectangle 11"/>
+      <p:pic>
+        <p:nvPicPr>
+          <p:cNvPr id="11" name="Picture 10" descr="add-monitoring.png"/>
+          <p:cNvPicPr>
+            <a:picLocks noChangeAspect="1"/>
+          </p:cNvPicPr>
+          <p:nvPr/>
+        </p:nvPicPr>
+        <p:blipFill>
+          <a:blip r:embed="rId2"/>
+          <a:stretch>
+            <a:fillRect/>
+          </a:stretch>
+        </p:blipFill>
+        <p:spPr>
+          <a:xfrm>
+            <a:off x="676656" y="1947672"/>
+            <a:ext cx="329184" cy="329184"/>
+          </a:xfrm>
+          <a:prstGeom prst="rect">
+            <a:avLst/>
+          </a:prstGeom>
+          <a:effectLst/>
+        </p:spPr>
+      </p:pic>
+      <p:sp>
+        <p:nvSpPr>
+          <p:cNvPr id="12" name="TextBox 11"/>
+          <p:cNvSpPr txBox="1"/>
+          <p:nvPr/>
+        </p:nvSpPr>
+        <p:spPr>
+          <a:xfrm>
+            <a:off x="676656" y="2350008"/>
+            <a:ext cx="1865376" cy="219456"/>
+          </a:xfrm>
+          <a:prstGeom prst="rect">
+            <a:avLst/>
+          </a:prstGeom>
+          <a:noFill/>
+        </p:spPr>
+        <p:txBody>
+          <a:bodyPr wrap="square" anchor="t" lIns="0" rIns="0" tIns="0" bIns="0">
+            <a:spAutoFit/>
+          </a:bodyPr>
+          <a:lstStyle/>
+          <a:p>
+            <a:pPr algn="l">
+              <a:spcAft>
+                <a:spcPts val="0"/>
+              </a:spcAft>
+            </a:pPr>
+            <a:r>
+              <a:rPr sz="950" b="1">
+                <a:solidFill>
+                  <a:srgbClr val="10182B"/>
+                </a:solidFill>
+                <a:latin typeface="Segoe UI"/>
+              </a:rPr>
+              <a:t>Add Monitoring</a:t>
+            </a:r>
+          </a:p>
+        </p:txBody>
+      </p:sp>
+      <p:sp>
+        <p:nvSpPr>
+          <p:cNvPr id="13" name="TextBox 12"/>
+          <p:cNvSpPr txBox="1"/>
+          <p:nvPr/>
+        </p:nvSpPr>
+        <p:spPr>
+          <a:xfrm>
+            <a:off x="676656" y="2560320"/>
+            <a:ext cx="1865376" cy="310896"/>
+          </a:xfrm>
+          <a:prstGeom prst="rect">
+            <a:avLst/>
+          </a:prstGeom>
+          <a:noFill/>
+        </p:spPr>
+        <p:txBody>
+          <a:bodyPr wrap="square" anchor="t" lIns="0" rIns="0" tIns="0" bIns="0">
+            <a:spAutoFit/>
+          </a:bodyPr>
+          <a:lstStyle/>
+          <a:p>
+            <a:pPr algn="l">
+              <a:spcAft>
+                <a:spcPts val="0"/>
+              </a:spcAft>
+            </a:pPr>
+            <a:r>
+              <a:rPr sz="750" b="0">
+                <a:solidFill>
+                  <a:srgbClr val="55637D"/>
+                </a:solidFill>
+                <a:latin typeface="Segoe UI"/>
+              </a:rPr>
+              <a:t>CMD, log &amp; process alerts — auto-routed to the right platform</a:t>
+            </a:r>
+          </a:p>
+        </p:txBody>
+      </p:sp>
+      <p:sp>
+        <p:nvSpPr>
+          <p:cNvPr id="14" name="TextBox 13"/>
+          <p:cNvSpPr txBox="1"/>
+          <p:nvPr/>
+        </p:nvSpPr>
+        <p:spPr>
+          <a:xfrm>
+            <a:off x="676656" y="2907791"/>
+            <a:ext cx="1865376" cy="182880"/>
+          </a:xfrm>
+          <a:prstGeom prst="rect">
+            <a:avLst/>
+          </a:prstGeom>
+          <a:noFill/>
+        </p:spPr>
+        <p:txBody>
+          <a:bodyPr wrap="square" anchor="t" lIns="0" rIns="0" tIns="0" bIns="0">
+            <a:spAutoFit/>
+          </a:bodyPr>
+          <a:lstStyle/>
+          <a:p>
+            <a:pPr algn="l">
+              <a:spcAft>
+                <a:spcPts val="0"/>
+              </a:spcAft>
+            </a:pPr>
+            <a:r>
+              <a:rPr sz="750" b="1">
+                <a:solidFill>
+                  <a:srgbClr val="DA2837"/>
+                </a:solidFill>
+                <a:latin typeface="Segoe UI"/>
+              </a:rPr>
+              <a:t>Launch template  →</a:t>
+            </a:r>
+          </a:p>
+        </p:txBody>
+      </p:sp>
+      <p:sp>
+        <p:nvSpPr>
+          <p:cNvPr id="15" name="Rounded Rectangle 14"/>
           <p:cNvSpPr/>
           <p:nvPr/>
         </p:nvSpPr>
         <p:spPr>
           <a:xfrm>
-            <a:off x="548640" y="2395728"/>
-            <a:ext cx="2121408" cy="36576"/>
+            <a:off x="548640" y="3255264"/>
+            <a:ext cx="2121408" cy="1298448"/>
+          </a:xfrm>
+          <a:prstGeom prst="roundRect">
+            <a:avLst>
+              <a:gd name="adj" fmla="val 9000"/>
+            </a:avLst>
+          </a:prstGeom>
+          <a:solidFill>
+            <a:srgbClr val="FFFFFF"/>
+          </a:solidFill>
+          <a:ln w="9525">
+            <a:solidFill>
+              <a:srgbClr val="E1E6EF"/>
+            </a:solidFill>
+          </a:ln>
+          <a:effectLst/>
+        </p:spPr>
+        <p:style>
+          <a:lnRef idx="1">
+            <a:schemeClr val="accent1"/>
+          </a:lnRef>
+          <a:fillRef idx="3">
+            <a:schemeClr val="accent1"/>
+          </a:fillRef>
+          <a:effectRef idx="2">
+            <a:schemeClr val="accent1"/>
+          </a:effectRef>
+          <a:fontRef idx="minor">
+            <a:schemeClr val="lt1"/>
+          </a:fontRef>
+        </p:style>
+        <p:txBody>
+          <a:bodyPr rtlCol="0" anchor="ctr"/>
+          <a:lstStyle/>
+          <a:p>
+            <a:pPr algn="ctr"/>
+          </a:p>
+        </p:txBody>
+      </p:sp>
+      <p:pic>
+        <p:nvPicPr>
+          <p:cNvPr id="16" name="Picture 15" descr="register-asset.png"/>
+          <p:cNvPicPr>
+            <a:picLocks noChangeAspect="1"/>
+          </p:cNvPicPr>
+          <p:nvPr/>
+        </p:nvPicPr>
+        <p:blipFill>
+          <a:blip r:embed="rId3"/>
+          <a:stretch>
+            <a:fillRect/>
+          </a:stretch>
+        </p:blipFill>
+        <p:spPr>
+          <a:xfrm>
+            <a:off x="676656" y="3374136"/>
+            <a:ext cx="329184" cy="329184"/>
+          </a:xfrm>
+          <a:prstGeom prst="rect">
+            <a:avLst/>
+          </a:prstGeom>
+          <a:effectLst/>
+        </p:spPr>
+      </p:pic>
+      <p:sp>
+        <p:nvSpPr>
+          <p:cNvPr id="17" name="TextBox 16"/>
+          <p:cNvSpPr txBox="1"/>
+          <p:nvPr/>
+        </p:nvSpPr>
+        <p:spPr>
+          <a:xfrm>
+            <a:off x="676656" y="3776472"/>
+            <a:ext cx="1865376" cy="219456"/>
+          </a:xfrm>
+          <a:prstGeom prst="rect">
+            <a:avLst/>
+          </a:prstGeom>
+          <a:noFill/>
+        </p:spPr>
+        <p:txBody>
+          <a:bodyPr wrap="square" anchor="t" lIns="0" rIns="0" tIns="0" bIns="0">
+            <a:spAutoFit/>
+          </a:bodyPr>
+          <a:lstStyle/>
+          <a:p>
+            <a:pPr algn="l">
+              <a:spcAft>
+                <a:spcPts val="0"/>
+              </a:spcAft>
+            </a:pPr>
+            <a:r>
+              <a:rPr sz="950" b="1">
+                <a:solidFill>
+                  <a:srgbClr val="10182B"/>
+                </a:solidFill>
+                <a:latin typeface="Segoe UI"/>
+              </a:rPr>
+              <a:t>Register Asset</a:t>
+            </a:r>
+          </a:p>
+        </p:txBody>
+      </p:sp>
+      <p:sp>
+        <p:nvSpPr>
+          <p:cNvPr id="18" name="TextBox 17"/>
+          <p:cNvSpPr txBox="1"/>
+          <p:nvPr/>
+        </p:nvSpPr>
+        <p:spPr>
+          <a:xfrm>
+            <a:off x="676656" y="3986784"/>
+            <a:ext cx="1865376" cy="310896"/>
+          </a:xfrm>
+          <a:prstGeom prst="rect">
+            <a:avLst/>
+          </a:prstGeom>
+          <a:noFill/>
+        </p:spPr>
+        <p:txBody>
+          <a:bodyPr wrap="square" anchor="t" lIns="0" rIns="0" tIns="0" bIns="0">
+            <a:spAutoFit/>
+          </a:bodyPr>
+          <a:lstStyle/>
+          <a:p>
+            <a:pPr algn="l">
+              <a:spcAft>
+                <a:spcPts val="0"/>
+              </a:spcAft>
+            </a:pPr>
+            <a:r>
+              <a:rPr sz="750" b="0">
+                <a:solidFill>
+                  <a:srgbClr val="55637D"/>
+                </a:solidFill>
+                <a:latin typeface="Segoe UI"/>
+              </a:rPr>
+              <a:t>Ad-hoc registration into the catalog</a:t>
+            </a:r>
+          </a:p>
+        </p:txBody>
+      </p:sp>
+      <p:sp>
+        <p:nvSpPr>
+          <p:cNvPr id="19" name="TextBox 18"/>
+          <p:cNvSpPr txBox="1"/>
+          <p:nvPr/>
+        </p:nvSpPr>
+        <p:spPr>
+          <a:xfrm>
+            <a:off x="676656" y="4334256"/>
+            <a:ext cx="1865376" cy="182880"/>
+          </a:xfrm>
+          <a:prstGeom prst="rect">
+            <a:avLst/>
+          </a:prstGeom>
+          <a:noFill/>
+        </p:spPr>
+        <p:txBody>
+          <a:bodyPr wrap="square" anchor="t" lIns="0" rIns="0" tIns="0" bIns="0">
+            <a:spAutoFit/>
+          </a:bodyPr>
+          <a:lstStyle/>
+          <a:p>
+            <a:pPr algn="l">
+              <a:spcAft>
+                <a:spcPts val="0"/>
+              </a:spcAft>
+            </a:pPr>
+            <a:r>
+              <a:rPr sz="750" b="1">
+                <a:solidFill>
+                  <a:srgbClr val="00ADE4"/>
+                </a:solidFill>
+                <a:latin typeface="Segoe UI"/>
+              </a:rPr>
+              <a:t>Register now  →</a:t>
+            </a:r>
+          </a:p>
+        </p:txBody>
+      </p:sp>
+      <p:sp>
+        <p:nvSpPr>
+          <p:cNvPr id="20" name="TextBox 19"/>
+          <p:cNvSpPr txBox="1"/>
+          <p:nvPr/>
+        </p:nvSpPr>
+        <p:spPr>
+          <a:xfrm>
+            <a:off x="2788920" y="1298448"/>
+            <a:ext cx="2121408" cy="219456"/>
+          </a:xfrm>
+          <a:prstGeom prst="rect">
+            <a:avLst/>
+          </a:prstGeom>
+          <a:noFill/>
+        </p:spPr>
+        <p:txBody>
+          <a:bodyPr wrap="square" anchor="t" lIns="0" rIns="0" tIns="0" bIns="0">
+            <a:spAutoFit/>
+          </a:bodyPr>
+          <a:lstStyle/>
+          <a:p>
+            <a:pPr algn="l">
+              <a:spcAft>
+                <a:spcPts val="400"/>
+              </a:spcAft>
+            </a:pPr>
+            <a:r>
+              <a:rPr sz="1100" b="1">
+                <a:solidFill>
+                  <a:srgbClr val="2E74B5"/>
+                </a:solidFill>
+                <a:latin typeface="Segoe UI"/>
+              </a:rPr>
+              <a:t>Q4 2026</a:t>
+            </a:r>
+          </a:p>
+        </p:txBody>
+      </p:sp>
+      <p:sp>
+        <p:nvSpPr>
+          <p:cNvPr id="21" name="TextBox 20"/>
+          <p:cNvSpPr txBox="1"/>
+          <p:nvPr/>
+        </p:nvSpPr>
+        <p:spPr>
+          <a:xfrm>
+            <a:off x="2788920" y="1508760"/>
+            <a:ext cx="2121408" cy="164592"/>
+          </a:xfrm>
+          <a:prstGeom prst="rect">
+            <a:avLst/>
+          </a:prstGeom>
+          <a:noFill/>
+        </p:spPr>
+        <p:txBody>
+          <a:bodyPr wrap="square" anchor="t" lIns="0" rIns="0" tIns="0" bIns="0">
+            <a:spAutoFit/>
+          </a:bodyPr>
+          <a:lstStyle/>
+          <a:p>
+            <a:pPr algn="l">
+              <a:spcAft>
+                <a:spcPts val="400"/>
+              </a:spcAft>
+            </a:pPr>
+            <a:r>
+              <a:rPr sz="800" b="1">
+                <a:solidFill>
+                  <a:srgbClr val="7A808A"/>
+                </a:solidFill>
+                <a:latin typeface="Segoe UI"/>
+              </a:rPr>
+              <a:t>LOGS &amp; AGENTS</a:t>
+            </a:r>
+          </a:p>
+        </p:txBody>
+      </p:sp>
+      <p:sp>
+        <p:nvSpPr>
+          <p:cNvPr id="22" name="Rectangle 21"/>
+          <p:cNvSpPr/>
+          <p:nvPr/>
+        </p:nvSpPr>
+        <p:spPr>
+          <a:xfrm>
+            <a:off x="2788920" y="1700784"/>
+            <a:ext cx="457200" cy="25603"/>
           </a:xfrm>
           <a:prstGeom prst="rect">
             <a:avLst/>
@@ -12661,79 +13043,26 @@
       </p:sp>
       <p:sp>
         <p:nvSpPr>
-          <p:cNvPr id="13" name="TextBox 12"/>
-          <p:cNvSpPr txBox="1"/>
-          <p:nvPr/>
-        </p:nvSpPr>
-        <p:spPr>
-          <a:xfrm>
-            <a:off x="676656" y="2505456"/>
-            <a:ext cx="1865376" cy="859536"/>
-          </a:xfrm>
-          <a:prstGeom prst="rect">
-            <a:avLst/>
-          </a:prstGeom>
-          <a:noFill/>
-        </p:spPr>
-        <p:txBody>
-          <a:bodyPr wrap="square" anchor="t" lIns="0" rIns="0" tIns="0" bIns="0">
-            <a:spAutoFit/>
-          </a:bodyPr>
-          <a:lstStyle/>
-          <a:p>
-            <a:pPr algn="l">
-              <a:spcAft>
-                <a:spcPts val="200"/>
-              </a:spcAft>
-            </a:pPr>
-            <a:r>
-              <a:rPr sz="1000" b="1">
-                <a:solidFill>
-                  <a:srgbClr val="1B2A41"/>
-                </a:solidFill>
-                <a:latin typeface="Segoe UI"/>
-              </a:rPr>
-              <a:t>Add Monitoring</a:t>
-            </a:r>
-          </a:p>
-          <a:p>
-            <a:pPr algn="l">
-              <a:spcAft>
-                <a:spcPts val="200"/>
-              </a:spcAft>
-            </a:pPr>
-            <a:r>
-              <a:rPr sz="800" b="0">
-                <a:solidFill>
-                  <a:srgbClr val="40444B"/>
-                </a:solidFill>
-                <a:latin typeface="Segoe UI"/>
-              </a:rPr>
-              <a:t>CMD, log &amp; process alerts, auto-routed — DX UIM live; production 30 Sep</a:t>
-            </a:r>
-          </a:p>
-        </p:txBody>
-      </p:sp>
-      <p:sp>
-        <p:nvSpPr>
-          <p:cNvPr id="14" name="Rectangle 13"/>
+          <p:cNvPr id="23" name="Rounded Rectangle 22"/>
           <p:cNvSpPr/>
           <p:nvPr/>
         </p:nvSpPr>
         <p:spPr>
           <a:xfrm>
-            <a:off x="548640" y="3584448"/>
-            <a:ext cx="2121408" cy="1060704"/>
-          </a:xfrm>
-          <a:prstGeom prst="rect">
-            <a:avLst/>
+            <a:off x="2788920" y="1828800"/>
+            <a:ext cx="2121408" cy="1298448"/>
+          </a:xfrm>
+          <a:prstGeom prst="roundRect">
+            <a:avLst>
+              <a:gd name="adj" fmla="val 9000"/>
+            </a:avLst>
           </a:prstGeom>
           <a:solidFill>
             <a:srgbClr val="FFFFFF"/>
           </a:solidFill>
           <a:ln w="9525">
             <a:solidFill>
-              <a:srgbClr val="D8DCE1"/>
+              <a:srgbClr val="E1E6EF"/>
             </a:solidFill>
           </a:ln>
           <a:effectLst/>
@@ -12760,16 +13089,616 @@
           </a:p>
         </p:txBody>
       </p:sp>
-      <p:sp>
-        <p:nvSpPr>
-          <p:cNvPr id="15" name="Rectangle 14"/>
+      <p:pic>
+        <p:nvPicPr>
+          <p:cNvPr id="24" name="Picture 23" descr="elk-log-onboarding.png"/>
+          <p:cNvPicPr>
+            <a:picLocks noChangeAspect="1"/>
+          </p:cNvPicPr>
+          <p:nvPr/>
+        </p:nvPicPr>
+        <p:blipFill>
+          <a:blip r:embed="rId4"/>
+          <a:stretch>
+            <a:fillRect/>
+          </a:stretch>
+        </p:blipFill>
+        <p:spPr>
+          <a:xfrm>
+            <a:off x="2916936" y="1947672"/>
+            <a:ext cx="329184" cy="329184"/>
+          </a:xfrm>
+          <a:prstGeom prst="rect">
+            <a:avLst/>
+          </a:prstGeom>
+          <a:effectLst/>
+        </p:spPr>
+      </p:pic>
+      <p:sp>
+        <p:nvSpPr>
+          <p:cNvPr id="25" name="TextBox 24"/>
+          <p:cNvSpPr txBox="1"/>
+          <p:nvPr/>
+        </p:nvSpPr>
+        <p:spPr>
+          <a:xfrm>
+            <a:off x="2916936" y="2350008"/>
+            <a:ext cx="1865376" cy="219456"/>
+          </a:xfrm>
+          <a:prstGeom prst="rect">
+            <a:avLst/>
+          </a:prstGeom>
+          <a:noFill/>
+        </p:spPr>
+        <p:txBody>
+          <a:bodyPr wrap="square" anchor="t" lIns="0" rIns="0" tIns="0" bIns="0">
+            <a:spAutoFit/>
+          </a:bodyPr>
+          <a:lstStyle/>
+          <a:p>
+            <a:pPr algn="l">
+              <a:spcAft>
+                <a:spcPts val="0"/>
+              </a:spcAft>
+            </a:pPr>
+            <a:r>
+              <a:rPr sz="950" b="1">
+                <a:solidFill>
+                  <a:srgbClr val="10182B"/>
+                </a:solidFill>
+                <a:latin typeface="Segoe UI"/>
+              </a:rPr>
+              <a:t>ELK Log Onboarding</a:t>
+            </a:r>
+          </a:p>
+        </p:txBody>
+      </p:sp>
+      <p:sp>
+        <p:nvSpPr>
+          <p:cNvPr id="26" name="TextBox 25"/>
+          <p:cNvSpPr txBox="1"/>
+          <p:nvPr/>
+        </p:nvSpPr>
+        <p:spPr>
+          <a:xfrm>
+            <a:off x="2916936" y="2560320"/>
+            <a:ext cx="1865376" cy="310896"/>
+          </a:xfrm>
+          <a:prstGeom prst="rect">
+            <a:avLst/>
+          </a:prstGeom>
+          <a:noFill/>
+        </p:spPr>
+        <p:txBody>
+          <a:bodyPr wrap="square" anchor="t" lIns="0" rIns="0" tIns="0" bIns="0">
+            <a:spAutoFit/>
+          </a:bodyPr>
+          <a:lstStyle/>
+          <a:p>
+            <a:pPr algn="l">
+              <a:spcAft>
+                <a:spcPts val="0"/>
+              </a:spcAft>
+            </a:pPr>
+            <a:r>
+              <a:rPr sz="750" b="0">
+                <a:solidFill>
+                  <a:srgbClr val="55637D"/>
+                </a:solidFill>
+                <a:latin typeface="Segoe UI"/>
+              </a:rPr>
+              <a:t>Agents, Kafka, parsers, indices — one request</a:t>
+            </a:r>
+          </a:p>
+        </p:txBody>
+      </p:sp>
+      <p:sp>
+        <p:nvSpPr>
+          <p:cNvPr id="27" name="TextBox 26"/>
+          <p:cNvSpPr txBox="1"/>
+          <p:nvPr/>
+        </p:nvSpPr>
+        <p:spPr>
+          <a:xfrm>
+            <a:off x="2916936" y="2907791"/>
+            <a:ext cx="1865376" cy="182880"/>
+          </a:xfrm>
+          <a:prstGeom prst="rect">
+            <a:avLst/>
+          </a:prstGeom>
+          <a:noFill/>
+        </p:spPr>
+        <p:txBody>
+          <a:bodyPr wrap="square" anchor="t" lIns="0" rIns="0" tIns="0" bIns="0">
+            <a:spAutoFit/>
+          </a:bodyPr>
+          <a:lstStyle/>
+          <a:p>
+            <a:pPr algn="l">
+              <a:spcAft>
+                <a:spcPts val="0"/>
+              </a:spcAft>
+            </a:pPr>
+            <a:r>
+              <a:rPr sz="750" b="1">
+                <a:solidFill>
+                  <a:srgbClr val="0278D5"/>
+                </a:solidFill>
+                <a:latin typeface="Segoe UI"/>
+              </a:rPr>
+              <a:t>Start onboarding  →</a:t>
+            </a:r>
+          </a:p>
+        </p:txBody>
+      </p:sp>
+      <p:sp>
+        <p:nvSpPr>
+          <p:cNvPr id="28" name="Rounded Rectangle 27"/>
           <p:cNvSpPr/>
           <p:nvPr/>
         </p:nvSpPr>
         <p:spPr>
           <a:xfrm>
-            <a:off x="548640" y="3584448"/>
-            <a:ext cx="2121408" cy="36576"/>
+            <a:off x="2788920" y="3255264"/>
+            <a:ext cx="2121408" cy="1298448"/>
+          </a:xfrm>
+          <a:prstGeom prst="roundRect">
+            <a:avLst>
+              <a:gd name="adj" fmla="val 9000"/>
+            </a:avLst>
+          </a:prstGeom>
+          <a:solidFill>
+            <a:srgbClr val="FFFFFF"/>
+          </a:solidFill>
+          <a:ln w="9525">
+            <a:solidFill>
+              <a:srgbClr val="E1E6EF"/>
+            </a:solidFill>
+          </a:ln>
+          <a:effectLst/>
+        </p:spPr>
+        <p:style>
+          <a:lnRef idx="1">
+            <a:schemeClr val="accent1"/>
+          </a:lnRef>
+          <a:fillRef idx="3">
+            <a:schemeClr val="accent1"/>
+          </a:fillRef>
+          <a:effectRef idx="2">
+            <a:schemeClr val="accent1"/>
+          </a:effectRef>
+          <a:fontRef idx="minor">
+            <a:schemeClr val="lt1"/>
+          </a:fontRef>
+        </p:style>
+        <p:txBody>
+          <a:bodyPr rtlCol="0" anchor="ctr"/>
+          <a:lstStyle/>
+          <a:p>
+            <a:pPr algn="ctr"/>
+          </a:p>
+        </p:txBody>
+      </p:sp>
+      <p:pic>
+        <p:nvPicPr>
+          <p:cNvPr id="29" name="Picture 28" descr="install-agent.png"/>
+          <p:cNvPicPr>
+            <a:picLocks noChangeAspect="1"/>
+          </p:cNvPicPr>
+          <p:nvPr/>
+        </p:nvPicPr>
+        <p:blipFill>
+          <a:blip r:embed="rId5"/>
+          <a:stretch>
+            <a:fillRect/>
+          </a:stretch>
+        </p:blipFill>
+        <p:spPr>
+          <a:xfrm>
+            <a:off x="2916936" y="3374136"/>
+            <a:ext cx="329184" cy="329184"/>
+          </a:xfrm>
+          <a:prstGeom prst="rect">
+            <a:avLst/>
+          </a:prstGeom>
+          <a:effectLst/>
+        </p:spPr>
+      </p:pic>
+      <p:sp>
+        <p:nvSpPr>
+          <p:cNvPr id="30" name="TextBox 29"/>
+          <p:cNvSpPr txBox="1"/>
+          <p:nvPr/>
+        </p:nvSpPr>
+        <p:spPr>
+          <a:xfrm>
+            <a:off x="2916936" y="3776472"/>
+            <a:ext cx="1865376" cy="219456"/>
+          </a:xfrm>
+          <a:prstGeom prst="rect">
+            <a:avLst/>
+          </a:prstGeom>
+          <a:noFill/>
+        </p:spPr>
+        <p:txBody>
+          <a:bodyPr wrap="square" anchor="t" lIns="0" rIns="0" tIns="0" bIns="0">
+            <a:spAutoFit/>
+          </a:bodyPr>
+          <a:lstStyle/>
+          <a:p>
+            <a:pPr algn="l">
+              <a:spcAft>
+                <a:spcPts val="0"/>
+              </a:spcAft>
+            </a:pPr>
+            <a:r>
+              <a:rPr sz="950" b="1">
+                <a:solidFill>
+                  <a:srgbClr val="10182B"/>
+                </a:solidFill>
+                <a:latin typeface="Segoe UI"/>
+              </a:rPr>
+              <a:t>Install Agent</a:t>
+            </a:r>
+          </a:p>
+        </p:txBody>
+      </p:sp>
+      <p:sp>
+        <p:nvSpPr>
+          <p:cNvPr id="31" name="TextBox 30"/>
+          <p:cNvSpPr txBox="1"/>
+          <p:nvPr/>
+        </p:nvSpPr>
+        <p:spPr>
+          <a:xfrm>
+            <a:off x="2916936" y="3986784"/>
+            <a:ext cx="1865376" cy="310896"/>
+          </a:xfrm>
+          <a:prstGeom prst="rect">
+            <a:avLst/>
+          </a:prstGeom>
+          <a:noFill/>
+        </p:spPr>
+        <p:txBody>
+          <a:bodyPr wrap="square" anchor="t" lIns="0" rIns="0" tIns="0" bIns="0">
+            <a:spAutoFit/>
+          </a:bodyPr>
+          <a:lstStyle/>
+          <a:p>
+            <a:pPr algn="l">
+              <a:spcAft>
+                <a:spcPts val="0"/>
+              </a:spcAft>
+            </a:pPr>
+            <a:r>
+              <a:rPr sz="750" b="0">
+                <a:solidFill>
+                  <a:srgbClr val="55637D"/>
+                </a:solidFill>
+                <a:latin typeface="Segoe UI"/>
+              </a:rPr>
+              <a:t>The right agents per host — only what is missing</a:t>
+            </a:r>
+          </a:p>
+        </p:txBody>
+      </p:sp>
+      <p:sp>
+        <p:nvSpPr>
+          <p:cNvPr id="32" name="TextBox 31"/>
+          <p:cNvSpPr txBox="1"/>
+          <p:nvPr/>
+        </p:nvSpPr>
+        <p:spPr>
+          <a:xfrm>
+            <a:off x="2916936" y="4334256"/>
+            <a:ext cx="1865376" cy="182880"/>
+          </a:xfrm>
+          <a:prstGeom prst="rect">
+            <a:avLst/>
+          </a:prstGeom>
+          <a:noFill/>
+        </p:spPr>
+        <p:txBody>
+          <a:bodyPr wrap="square" anchor="t" lIns="0" rIns="0" tIns="0" bIns="0">
+            <a:spAutoFit/>
+          </a:bodyPr>
+          <a:lstStyle/>
+          <a:p>
+            <a:pPr algn="l">
+              <a:spcAft>
+                <a:spcPts val="0"/>
+              </a:spcAft>
+            </a:pPr>
+            <a:r>
+              <a:rPr sz="750" b="1">
+                <a:solidFill>
+                  <a:srgbClr val="0E8074"/>
+                </a:solidFill>
+                <a:latin typeface="Segoe UI"/>
+              </a:rPr>
+              <a:t>Install agents  →</a:t>
+            </a:r>
+          </a:p>
+        </p:txBody>
+      </p:sp>
+      <p:sp>
+        <p:nvSpPr>
+          <p:cNvPr id="33" name="Rounded Rectangle 32"/>
+          <p:cNvSpPr/>
+          <p:nvPr/>
+        </p:nvSpPr>
+        <p:spPr>
+          <a:xfrm>
+            <a:off x="2788920" y="4681728"/>
+            <a:ext cx="2121408" cy="1298448"/>
+          </a:xfrm>
+          <a:prstGeom prst="roundRect">
+            <a:avLst>
+              <a:gd name="adj" fmla="val 9000"/>
+            </a:avLst>
+          </a:prstGeom>
+          <a:solidFill>
+            <a:srgbClr val="FFFFFF"/>
+          </a:solidFill>
+          <a:ln w="9525">
+            <a:solidFill>
+              <a:srgbClr val="E1E6EF"/>
+            </a:solidFill>
+          </a:ln>
+          <a:effectLst/>
+        </p:spPr>
+        <p:style>
+          <a:lnRef idx="1">
+            <a:schemeClr val="accent1"/>
+          </a:lnRef>
+          <a:fillRef idx="3">
+            <a:schemeClr val="accent1"/>
+          </a:fillRef>
+          <a:effectRef idx="2">
+            <a:schemeClr val="accent1"/>
+          </a:effectRef>
+          <a:fontRef idx="minor">
+            <a:schemeClr val="lt1"/>
+          </a:fontRef>
+        </p:style>
+        <p:txBody>
+          <a:bodyPr rtlCol="0" anchor="ctr"/>
+          <a:lstStyle/>
+          <a:p>
+            <a:pPr algn="ctr"/>
+          </a:p>
+        </p:txBody>
+      </p:sp>
+      <p:pic>
+        <p:nvPicPr>
+          <p:cNvPr id="34" name="Picture 33" descr="request-log-access.png"/>
+          <p:cNvPicPr>
+            <a:picLocks noChangeAspect="1"/>
+          </p:cNvPicPr>
+          <p:nvPr/>
+        </p:nvPicPr>
+        <p:blipFill>
+          <a:blip r:embed="rId6"/>
+          <a:stretch>
+            <a:fillRect/>
+          </a:stretch>
+        </p:blipFill>
+        <p:spPr>
+          <a:xfrm>
+            <a:off x="2916936" y="4800600"/>
+            <a:ext cx="329184" cy="329184"/>
+          </a:xfrm>
+          <a:prstGeom prst="rect">
+            <a:avLst/>
+          </a:prstGeom>
+          <a:effectLst/>
+        </p:spPr>
+      </p:pic>
+      <p:sp>
+        <p:nvSpPr>
+          <p:cNvPr id="35" name="TextBox 34"/>
+          <p:cNvSpPr txBox="1"/>
+          <p:nvPr/>
+        </p:nvSpPr>
+        <p:spPr>
+          <a:xfrm>
+            <a:off x="2916936" y="5202936"/>
+            <a:ext cx="1865376" cy="219456"/>
+          </a:xfrm>
+          <a:prstGeom prst="rect">
+            <a:avLst/>
+          </a:prstGeom>
+          <a:noFill/>
+        </p:spPr>
+        <p:txBody>
+          <a:bodyPr wrap="square" anchor="t" lIns="0" rIns="0" tIns="0" bIns="0">
+            <a:spAutoFit/>
+          </a:bodyPr>
+          <a:lstStyle/>
+          <a:p>
+            <a:pPr algn="l">
+              <a:spcAft>
+                <a:spcPts val="0"/>
+              </a:spcAft>
+            </a:pPr>
+            <a:r>
+              <a:rPr sz="950" b="1">
+                <a:solidFill>
+                  <a:srgbClr val="10182B"/>
+                </a:solidFill>
+                <a:latin typeface="Segoe UI"/>
+              </a:rPr>
+              <a:t>Request Log Access</a:t>
+            </a:r>
+          </a:p>
+        </p:txBody>
+      </p:sp>
+      <p:sp>
+        <p:nvSpPr>
+          <p:cNvPr id="36" name="TextBox 35"/>
+          <p:cNvSpPr txBox="1"/>
+          <p:nvPr/>
+        </p:nvSpPr>
+        <p:spPr>
+          <a:xfrm>
+            <a:off x="2916936" y="5413248"/>
+            <a:ext cx="1865376" cy="310896"/>
+          </a:xfrm>
+          <a:prstGeom prst="rect">
+            <a:avLst/>
+          </a:prstGeom>
+          <a:noFill/>
+        </p:spPr>
+        <p:txBody>
+          <a:bodyPr wrap="square" anchor="t" lIns="0" rIns="0" tIns="0" bIns="0">
+            <a:spAutoFit/>
+          </a:bodyPr>
+          <a:lstStyle/>
+          <a:p>
+            <a:pPr algn="l">
+              <a:spcAft>
+                <a:spcPts val="0"/>
+              </a:spcAft>
+            </a:pPr>
+            <a:r>
+              <a:rPr sz="750" b="0">
+                <a:solidFill>
+                  <a:srgbClr val="55637D"/>
+                </a:solidFill>
+                <a:latin typeface="Segoe UI"/>
+              </a:rPr>
+              <a:t>Read-only ELK index access, on request</a:t>
+            </a:r>
+          </a:p>
+        </p:txBody>
+      </p:sp>
+      <p:sp>
+        <p:nvSpPr>
+          <p:cNvPr id="37" name="TextBox 36"/>
+          <p:cNvSpPr txBox="1"/>
+          <p:nvPr/>
+        </p:nvSpPr>
+        <p:spPr>
+          <a:xfrm>
+            <a:off x="2916936" y="5760720"/>
+            <a:ext cx="1865376" cy="182880"/>
+          </a:xfrm>
+          <a:prstGeom prst="rect">
+            <a:avLst/>
+          </a:prstGeom>
+          <a:noFill/>
+        </p:spPr>
+        <p:txBody>
+          <a:bodyPr wrap="square" anchor="t" lIns="0" rIns="0" tIns="0" bIns="0">
+            <a:spAutoFit/>
+          </a:bodyPr>
+          <a:lstStyle/>
+          <a:p>
+            <a:pPr algn="l">
+              <a:spcAft>
+                <a:spcPts val="0"/>
+              </a:spcAft>
+            </a:pPr>
+            <a:r>
+              <a:rPr sz="750" b="1">
+                <a:solidFill>
+                  <a:srgbClr val="6938F2"/>
+                </a:solidFill>
+                <a:latin typeface="Segoe UI"/>
+              </a:rPr>
+              <a:t>Request access  →</a:t>
+            </a:r>
+          </a:p>
+        </p:txBody>
+      </p:sp>
+      <p:sp>
+        <p:nvSpPr>
+          <p:cNvPr id="38" name="TextBox 37"/>
+          <p:cNvSpPr txBox="1"/>
+          <p:nvPr/>
+        </p:nvSpPr>
+        <p:spPr>
+          <a:xfrm>
+            <a:off x="5029199" y="1298448"/>
+            <a:ext cx="2121408" cy="219456"/>
+          </a:xfrm>
+          <a:prstGeom prst="rect">
+            <a:avLst/>
+          </a:prstGeom>
+          <a:noFill/>
+        </p:spPr>
+        <p:txBody>
+          <a:bodyPr wrap="square" anchor="t" lIns="0" rIns="0" tIns="0" bIns="0">
+            <a:spAutoFit/>
+          </a:bodyPr>
+          <a:lstStyle/>
+          <a:p>
+            <a:pPr algn="l">
+              <a:spcAft>
+                <a:spcPts val="400"/>
+              </a:spcAft>
+            </a:pPr>
+            <a:r>
+              <a:rPr sz="1100" b="1">
+                <a:solidFill>
+                  <a:srgbClr val="2E74B5"/>
+                </a:solidFill>
+                <a:latin typeface="Segoe UI"/>
+              </a:rPr>
+              <a:t>Q1 2027</a:t>
+            </a:r>
+          </a:p>
+        </p:txBody>
+      </p:sp>
+      <p:sp>
+        <p:nvSpPr>
+          <p:cNvPr id="39" name="TextBox 38"/>
+          <p:cNvSpPr txBox="1"/>
+          <p:nvPr/>
+        </p:nvSpPr>
+        <p:spPr>
+          <a:xfrm>
+            <a:off x="5029199" y="1508760"/>
+            <a:ext cx="2121408" cy="164592"/>
+          </a:xfrm>
+          <a:prstGeom prst="rect">
+            <a:avLst/>
+          </a:prstGeom>
+          <a:noFill/>
+        </p:spPr>
+        <p:txBody>
+          <a:bodyPr wrap="square" anchor="t" lIns="0" rIns="0" tIns="0" bIns="0">
+            <a:spAutoFit/>
+          </a:bodyPr>
+          <a:lstStyle/>
+          <a:p>
+            <a:pPr algn="l">
+              <a:spcAft>
+                <a:spcPts val="400"/>
+              </a:spcAft>
+            </a:pPr>
+            <a:r>
+              <a:rPr sz="800" b="1">
+                <a:solidFill>
+                  <a:srgbClr val="7A808A"/>
+                </a:solidFill>
+                <a:latin typeface="Segoe UI"/>
+              </a:rPr>
+              <a:t>VISIBILITY</a:t>
+            </a:r>
+          </a:p>
+        </p:txBody>
+      </p:sp>
+      <p:sp>
+        <p:nvSpPr>
+          <p:cNvPr id="40" name="Rectangle 39"/>
+          <p:cNvSpPr/>
+          <p:nvPr/>
+        </p:nvSpPr>
+        <p:spPr>
+          <a:xfrm>
+            <a:off x="5029199" y="1700784"/>
+            <a:ext cx="457200" cy="25603"/>
           </a:xfrm>
           <a:prstGeom prst="rect">
             <a:avLst/>
@@ -12806,69 +13735,584 @@
       </p:sp>
       <p:sp>
         <p:nvSpPr>
-          <p:cNvPr id="16" name="TextBox 15"/>
-          <p:cNvSpPr txBox="1"/>
-          <p:nvPr/>
-        </p:nvSpPr>
-        <p:spPr>
-          <a:xfrm>
-            <a:off x="676656" y="3694176"/>
-            <a:ext cx="1865376" cy="859536"/>
-          </a:xfrm>
-          <a:prstGeom prst="rect">
-            <a:avLst/>
-          </a:prstGeom>
-          <a:noFill/>
-        </p:spPr>
-        <p:txBody>
-          <a:bodyPr wrap="square" anchor="t" lIns="0" rIns="0" tIns="0" bIns="0">
-            <a:spAutoFit/>
-          </a:bodyPr>
-          <a:lstStyle/>
-          <a:p>
-            <a:pPr algn="l">
-              <a:spcAft>
-                <a:spcPts val="200"/>
-              </a:spcAft>
-            </a:pPr>
-            <a:r>
-              <a:rPr sz="1000" b="1">
-                <a:solidFill>
-                  <a:srgbClr val="1B2A41"/>
-                </a:solidFill>
-                <a:latin typeface="Segoe UI"/>
-              </a:rPr>
-              <a:t>Register Asset</a:t>
-            </a:r>
-          </a:p>
-          <a:p>
-            <a:pPr algn="l">
-              <a:spcAft>
-                <a:spcPts val="200"/>
-              </a:spcAft>
-            </a:pPr>
-            <a:r>
-              <a:rPr sz="800" b="0">
-                <a:solidFill>
-                  <a:srgbClr val="40444B"/>
-                </a:solidFill>
-                <a:latin typeface="Segoe UI"/>
-              </a:rPr>
-              <a:t>Ad-hoc registration of servers and dashboards into the catalog</a:t>
-            </a:r>
-          </a:p>
-        </p:txBody>
-      </p:sp>
-      <p:sp>
-        <p:nvSpPr>
-          <p:cNvPr id="17" name="TextBox 16"/>
-          <p:cNvSpPr txBox="1"/>
-          <p:nvPr/>
-        </p:nvSpPr>
-        <p:spPr>
-          <a:xfrm>
-            <a:off x="2788920" y="1810512"/>
-            <a:ext cx="2121408" cy="237744"/>
+          <p:cNvPr id="41" name="Rounded Rectangle 40"/>
+          <p:cNvSpPr/>
+          <p:nvPr/>
+        </p:nvSpPr>
+        <p:spPr>
+          <a:xfrm>
+            <a:off x="5029199" y="1828800"/>
+            <a:ext cx="2121408" cy="1298448"/>
+          </a:xfrm>
+          <a:prstGeom prst="roundRect">
+            <a:avLst>
+              <a:gd name="adj" fmla="val 9000"/>
+            </a:avLst>
+          </a:prstGeom>
+          <a:solidFill>
+            <a:srgbClr val="FFFFFF"/>
+          </a:solidFill>
+          <a:ln w="9525">
+            <a:solidFill>
+              <a:srgbClr val="E1E6EF"/>
+            </a:solidFill>
+          </a:ln>
+          <a:effectLst/>
+        </p:spPr>
+        <p:style>
+          <a:lnRef idx="1">
+            <a:schemeClr val="accent1"/>
+          </a:lnRef>
+          <a:fillRef idx="3">
+            <a:schemeClr val="accent1"/>
+          </a:fillRef>
+          <a:effectRef idx="2">
+            <a:schemeClr val="accent1"/>
+          </a:effectRef>
+          <a:fontRef idx="minor">
+            <a:schemeClr val="lt1"/>
+          </a:fontRef>
+        </p:style>
+        <p:txBody>
+          <a:bodyPr rtlCol="0" anchor="ctr"/>
+          <a:lstStyle/>
+          <a:p>
+            <a:pPr algn="ctr"/>
+          </a:p>
+        </p:txBody>
+      </p:sp>
+      <p:pic>
+        <p:nvPicPr>
+          <p:cNvPr id="42" name="Picture 41" descr="reports.png"/>
+          <p:cNvPicPr>
+            <a:picLocks noChangeAspect="1"/>
+          </p:cNvPicPr>
+          <p:nvPr/>
+        </p:nvPicPr>
+        <p:blipFill>
+          <a:blip r:embed="rId7"/>
+          <a:stretch>
+            <a:fillRect/>
+          </a:stretch>
+        </p:blipFill>
+        <p:spPr>
+          <a:xfrm>
+            <a:off x="5157215" y="1947672"/>
+            <a:ext cx="329184" cy="329184"/>
+          </a:xfrm>
+          <a:prstGeom prst="rect">
+            <a:avLst/>
+          </a:prstGeom>
+          <a:effectLst/>
+        </p:spPr>
+      </p:pic>
+      <p:sp>
+        <p:nvSpPr>
+          <p:cNvPr id="43" name="TextBox 42"/>
+          <p:cNvSpPr txBox="1"/>
+          <p:nvPr/>
+        </p:nvSpPr>
+        <p:spPr>
+          <a:xfrm>
+            <a:off x="5157215" y="2350008"/>
+            <a:ext cx="1865376" cy="219456"/>
+          </a:xfrm>
+          <a:prstGeom prst="rect">
+            <a:avLst/>
+          </a:prstGeom>
+          <a:noFill/>
+        </p:spPr>
+        <p:txBody>
+          <a:bodyPr wrap="square" anchor="t" lIns="0" rIns="0" tIns="0" bIns="0">
+            <a:spAutoFit/>
+          </a:bodyPr>
+          <a:lstStyle/>
+          <a:p>
+            <a:pPr algn="l">
+              <a:spcAft>
+                <a:spcPts val="0"/>
+              </a:spcAft>
+            </a:pPr>
+            <a:r>
+              <a:rPr sz="950" b="1">
+                <a:solidFill>
+                  <a:srgbClr val="10182B"/>
+                </a:solidFill>
+                <a:latin typeface="Segoe UI"/>
+              </a:rPr>
+              <a:t>Reports</a:t>
+            </a:r>
+          </a:p>
+        </p:txBody>
+      </p:sp>
+      <p:sp>
+        <p:nvSpPr>
+          <p:cNvPr id="44" name="TextBox 43"/>
+          <p:cNvSpPr txBox="1"/>
+          <p:nvPr/>
+        </p:nvSpPr>
+        <p:spPr>
+          <a:xfrm>
+            <a:off x="5157215" y="2560320"/>
+            <a:ext cx="1865376" cy="310896"/>
+          </a:xfrm>
+          <a:prstGeom prst="rect">
+            <a:avLst/>
+          </a:prstGeom>
+          <a:noFill/>
+        </p:spPr>
+        <p:txBody>
+          <a:bodyPr wrap="square" anchor="t" lIns="0" rIns="0" tIns="0" bIns="0">
+            <a:spAutoFit/>
+          </a:bodyPr>
+          <a:lstStyle/>
+          <a:p>
+            <a:pPr algn="l">
+              <a:spcAft>
+                <a:spcPts val="0"/>
+              </a:spcAft>
+            </a:pPr>
+            <a:r>
+              <a:rPr sz="750" b="0">
+                <a:solidFill>
+                  <a:srgbClr val="55637D"/>
+                </a:solidFill>
+                <a:latin typeface="Segoe UI"/>
+              </a:rPr>
+              <a:t>Daily reconciliation — gaps, unmonitored, drift</a:t>
+            </a:r>
+          </a:p>
+        </p:txBody>
+      </p:sp>
+      <p:sp>
+        <p:nvSpPr>
+          <p:cNvPr id="45" name="TextBox 44"/>
+          <p:cNvSpPr txBox="1"/>
+          <p:nvPr/>
+        </p:nvSpPr>
+        <p:spPr>
+          <a:xfrm>
+            <a:off x="5157215" y="2907791"/>
+            <a:ext cx="1865376" cy="182880"/>
+          </a:xfrm>
+          <a:prstGeom prst="rect">
+            <a:avLst/>
+          </a:prstGeom>
+          <a:noFill/>
+        </p:spPr>
+        <p:txBody>
+          <a:bodyPr wrap="square" anchor="t" lIns="0" rIns="0" tIns="0" bIns="0">
+            <a:spAutoFit/>
+          </a:bodyPr>
+          <a:lstStyle/>
+          <a:p>
+            <a:pPr algn="l">
+              <a:spcAft>
+                <a:spcPts val="0"/>
+              </a:spcAft>
+            </a:pPr>
+            <a:r>
+              <a:rPr sz="750" b="1">
+                <a:solidFill>
+                  <a:srgbClr val="00B8A9"/>
+                </a:solidFill>
+                <a:latin typeface="Segoe UI"/>
+              </a:rPr>
+              <a:t>View reports  →</a:t>
+            </a:r>
+          </a:p>
+        </p:txBody>
+      </p:sp>
+      <p:sp>
+        <p:nvSpPr>
+          <p:cNvPr id="46" name="Rounded Rectangle 45"/>
+          <p:cNvSpPr/>
+          <p:nvPr/>
+        </p:nvSpPr>
+        <p:spPr>
+          <a:xfrm>
+            <a:off x="5029199" y="3255264"/>
+            <a:ext cx="2121408" cy="1298448"/>
+          </a:xfrm>
+          <a:prstGeom prst="roundRect">
+            <a:avLst>
+              <a:gd name="adj" fmla="val 9000"/>
+            </a:avLst>
+          </a:prstGeom>
+          <a:solidFill>
+            <a:srgbClr val="FFFFFF"/>
+          </a:solidFill>
+          <a:ln w="9525">
+            <a:solidFill>
+              <a:srgbClr val="E1E6EF"/>
+            </a:solidFill>
+          </a:ln>
+          <a:effectLst/>
+        </p:spPr>
+        <p:style>
+          <a:lnRef idx="1">
+            <a:schemeClr val="accent1"/>
+          </a:lnRef>
+          <a:fillRef idx="3">
+            <a:schemeClr val="accent1"/>
+          </a:fillRef>
+          <a:effectRef idx="2">
+            <a:schemeClr val="accent1"/>
+          </a:effectRef>
+          <a:fontRef idx="minor">
+            <a:schemeClr val="lt1"/>
+          </a:fontRef>
+        </p:style>
+        <p:txBody>
+          <a:bodyPr rtlCol="0" anchor="ctr"/>
+          <a:lstStyle/>
+          <a:p>
+            <a:pPr algn="ctr"/>
+          </a:p>
+        </p:txBody>
+      </p:sp>
+      <p:pic>
+        <p:nvPicPr>
+          <p:cNvPr id="47" name="Picture 46" descr="dashboard-inventory.png"/>
+          <p:cNvPicPr>
+            <a:picLocks noChangeAspect="1"/>
+          </p:cNvPicPr>
+          <p:nvPr/>
+        </p:nvPicPr>
+        <p:blipFill>
+          <a:blip r:embed="rId8"/>
+          <a:stretch>
+            <a:fillRect/>
+          </a:stretch>
+        </p:blipFill>
+        <p:spPr>
+          <a:xfrm>
+            <a:off x="5157215" y="3374136"/>
+            <a:ext cx="329184" cy="329184"/>
+          </a:xfrm>
+          <a:prstGeom prst="rect">
+            <a:avLst/>
+          </a:prstGeom>
+          <a:effectLst/>
+        </p:spPr>
+      </p:pic>
+      <p:sp>
+        <p:nvSpPr>
+          <p:cNvPr id="48" name="TextBox 47"/>
+          <p:cNvSpPr txBox="1"/>
+          <p:nvPr/>
+        </p:nvSpPr>
+        <p:spPr>
+          <a:xfrm>
+            <a:off x="5157215" y="3776472"/>
+            <a:ext cx="1865376" cy="219456"/>
+          </a:xfrm>
+          <a:prstGeom prst="rect">
+            <a:avLst/>
+          </a:prstGeom>
+          <a:noFill/>
+        </p:spPr>
+        <p:txBody>
+          <a:bodyPr wrap="square" anchor="t" lIns="0" rIns="0" tIns="0" bIns="0">
+            <a:spAutoFit/>
+          </a:bodyPr>
+          <a:lstStyle/>
+          <a:p>
+            <a:pPr algn="l">
+              <a:spcAft>
+                <a:spcPts val="0"/>
+              </a:spcAft>
+            </a:pPr>
+            <a:r>
+              <a:rPr sz="950" b="1">
+                <a:solidFill>
+                  <a:srgbClr val="10182B"/>
+                </a:solidFill>
+                <a:latin typeface="Segoe UI"/>
+              </a:rPr>
+              <a:t>Dashboard Inventory</a:t>
+            </a:r>
+          </a:p>
+        </p:txBody>
+      </p:sp>
+      <p:sp>
+        <p:nvSpPr>
+          <p:cNvPr id="49" name="TextBox 48"/>
+          <p:cNvSpPr txBox="1"/>
+          <p:nvPr/>
+        </p:nvSpPr>
+        <p:spPr>
+          <a:xfrm>
+            <a:off x="5157215" y="3986784"/>
+            <a:ext cx="1865376" cy="310896"/>
+          </a:xfrm>
+          <a:prstGeom prst="rect">
+            <a:avLst/>
+          </a:prstGeom>
+          <a:noFill/>
+        </p:spPr>
+        <p:txBody>
+          <a:bodyPr wrap="square" anchor="t" lIns="0" rIns="0" tIns="0" bIns="0">
+            <a:spAutoFit/>
+          </a:bodyPr>
+          <a:lstStyle/>
+          <a:p>
+            <a:pPr algn="l">
+              <a:spcAft>
+                <a:spcPts val="0"/>
+              </a:spcAft>
+            </a:pPr>
+            <a:r>
+              <a:rPr sz="750" b="0">
+                <a:solidFill>
+                  <a:srgbClr val="55637D"/>
+                </a:solidFill>
+                <a:latin typeface="Segoe UI"/>
+              </a:rPr>
+              <a:t>Every dashboard described and linked</a:t>
+            </a:r>
+          </a:p>
+        </p:txBody>
+      </p:sp>
+      <p:sp>
+        <p:nvSpPr>
+          <p:cNvPr id="50" name="TextBox 49"/>
+          <p:cNvSpPr txBox="1"/>
+          <p:nvPr/>
+        </p:nvSpPr>
+        <p:spPr>
+          <a:xfrm>
+            <a:off x="5157215" y="4334256"/>
+            <a:ext cx="1865376" cy="182880"/>
+          </a:xfrm>
+          <a:prstGeom prst="rect">
+            <a:avLst/>
+          </a:prstGeom>
+          <a:noFill/>
+        </p:spPr>
+        <p:txBody>
+          <a:bodyPr wrap="square" anchor="t" lIns="0" rIns="0" tIns="0" bIns="0">
+            <a:spAutoFit/>
+          </a:bodyPr>
+          <a:lstStyle/>
+          <a:p>
+            <a:pPr algn="l">
+              <a:spcAft>
+                <a:spcPts val="0"/>
+              </a:spcAft>
+            </a:pPr>
+            <a:r>
+              <a:rPr sz="750" b="1">
+                <a:solidFill>
+                  <a:srgbClr val="B45309"/>
+                </a:solidFill>
+                <a:latin typeface="Segoe UI"/>
+              </a:rPr>
+              <a:t>Browse dashboards  →</a:t>
+            </a:r>
+          </a:p>
+        </p:txBody>
+      </p:sp>
+      <p:sp>
+        <p:nvSpPr>
+          <p:cNvPr id="51" name="Rounded Rectangle 50"/>
+          <p:cNvSpPr/>
+          <p:nvPr/>
+        </p:nvSpPr>
+        <p:spPr>
+          <a:xfrm>
+            <a:off x="5029199" y="4681728"/>
+            <a:ext cx="2121408" cy="1298448"/>
+          </a:xfrm>
+          <a:prstGeom prst="roundRect">
+            <a:avLst>
+              <a:gd name="adj" fmla="val 9000"/>
+            </a:avLst>
+          </a:prstGeom>
+          <a:solidFill>
+            <a:srgbClr val="FFFFFF"/>
+          </a:solidFill>
+          <a:ln w="9525">
+            <a:solidFill>
+              <a:srgbClr val="E1E6EF"/>
+            </a:solidFill>
+          </a:ln>
+          <a:effectLst/>
+        </p:spPr>
+        <p:style>
+          <a:lnRef idx="1">
+            <a:schemeClr val="accent1"/>
+          </a:lnRef>
+          <a:fillRef idx="3">
+            <a:schemeClr val="accent1"/>
+          </a:fillRef>
+          <a:effectRef idx="2">
+            <a:schemeClr val="accent1"/>
+          </a:effectRef>
+          <a:fontRef idx="minor">
+            <a:schemeClr val="lt1"/>
+          </a:fontRef>
+        </p:style>
+        <p:txBody>
+          <a:bodyPr rtlCol="0" anchor="ctr"/>
+          <a:lstStyle/>
+          <a:p>
+            <a:pPr algn="ctr"/>
+          </a:p>
+        </p:txBody>
+      </p:sp>
+      <p:pic>
+        <p:nvPicPr>
+          <p:cNvPr id="52" name="Picture 51" descr="data-dictionary.png"/>
+          <p:cNvPicPr>
+            <a:picLocks noChangeAspect="1"/>
+          </p:cNvPicPr>
+          <p:nvPr/>
+        </p:nvPicPr>
+        <p:blipFill>
+          <a:blip r:embed="rId9"/>
+          <a:stretch>
+            <a:fillRect/>
+          </a:stretch>
+        </p:blipFill>
+        <p:spPr>
+          <a:xfrm>
+            <a:off x="5157215" y="4800600"/>
+            <a:ext cx="329184" cy="329184"/>
+          </a:xfrm>
+          <a:prstGeom prst="rect">
+            <a:avLst/>
+          </a:prstGeom>
+          <a:effectLst/>
+        </p:spPr>
+      </p:pic>
+      <p:sp>
+        <p:nvSpPr>
+          <p:cNvPr id="53" name="TextBox 52"/>
+          <p:cNvSpPr txBox="1"/>
+          <p:nvPr/>
+        </p:nvSpPr>
+        <p:spPr>
+          <a:xfrm>
+            <a:off x="5157215" y="5202936"/>
+            <a:ext cx="1865376" cy="219456"/>
+          </a:xfrm>
+          <a:prstGeom prst="rect">
+            <a:avLst/>
+          </a:prstGeom>
+          <a:noFill/>
+        </p:spPr>
+        <p:txBody>
+          <a:bodyPr wrap="square" anchor="t" lIns="0" rIns="0" tIns="0" bIns="0">
+            <a:spAutoFit/>
+          </a:bodyPr>
+          <a:lstStyle/>
+          <a:p>
+            <a:pPr algn="l">
+              <a:spcAft>
+                <a:spcPts val="0"/>
+              </a:spcAft>
+            </a:pPr>
+            <a:r>
+              <a:rPr sz="950" b="1">
+                <a:solidFill>
+                  <a:srgbClr val="10182B"/>
+                </a:solidFill>
+                <a:latin typeface="Segoe UI"/>
+              </a:rPr>
+              <a:t>Data Dictionary</a:t>
+            </a:r>
+          </a:p>
+        </p:txBody>
+      </p:sp>
+      <p:sp>
+        <p:nvSpPr>
+          <p:cNvPr id="54" name="TextBox 53"/>
+          <p:cNvSpPr txBox="1"/>
+          <p:nvPr/>
+        </p:nvSpPr>
+        <p:spPr>
+          <a:xfrm>
+            <a:off x="5157215" y="5413248"/>
+            <a:ext cx="1865376" cy="310896"/>
+          </a:xfrm>
+          <a:prstGeom prst="rect">
+            <a:avLst/>
+          </a:prstGeom>
+          <a:noFill/>
+        </p:spPr>
+        <p:txBody>
+          <a:bodyPr wrap="square" anchor="t" lIns="0" rIns="0" tIns="0" bIns="0">
+            <a:spAutoFit/>
+          </a:bodyPr>
+          <a:lstStyle/>
+          <a:p>
+            <a:pPr algn="l">
+              <a:spcAft>
+                <a:spcPts val="0"/>
+              </a:spcAft>
+            </a:pPr>
+            <a:r>
+              <a:rPr sz="750" b="0">
+                <a:solidFill>
+                  <a:srgbClr val="55637D"/>
+                </a:solidFill>
+                <a:latin typeface="Segoe UI"/>
+              </a:rPr>
+              <a:t>Every ELK index and its function</a:t>
+            </a:r>
+          </a:p>
+        </p:txBody>
+      </p:sp>
+      <p:sp>
+        <p:nvSpPr>
+          <p:cNvPr id="55" name="TextBox 54"/>
+          <p:cNvSpPr txBox="1"/>
+          <p:nvPr/>
+        </p:nvSpPr>
+        <p:spPr>
+          <a:xfrm>
+            <a:off x="5157215" y="5760720"/>
+            <a:ext cx="1865376" cy="182880"/>
+          </a:xfrm>
+          <a:prstGeom prst="rect">
+            <a:avLst/>
+          </a:prstGeom>
+          <a:noFill/>
+        </p:spPr>
+        <p:txBody>
+          <a:bodyPr wrap="square" anchor="t" lIns="0" rIns="0" tIns="0" bIns="0">
+            <a:spAutoFit/>
+          </a:bodyPr>
+          <a:lstStyle/>
+          <a:p>
+            <a:pPr algn="l">
+              <a:spcAft>
+                <a:spcPts val="0"/>
+              </a:spcAft>
+            </a:pPr>
+            <a:r>
+              <a:rPr sz="750" b="1">
+                <a:solidFill>
+                  <a:srgbClr val="4F46E5"/>
+                </a:solidFill>
+                <a:latin typeface="Segoe UI"/>
+              </a:rPr>
+              <a:t>Browse dictionary  →</a:t>
+            </a:r>
+          </a:p>
+        </p:txBody>
+      </p:sp>
+      <p:sp>
+        <p:nvSpPr>
+          <p:cNvPr id="56" name="TextBox 55"/>
+          <p:cNvSpPr txBox="1"/>
+          <p:nvPr/>
+        </p:nvSpPr>
+        <p:spPr>
+          <a:xfrm>
+            <a:off x="7269479" y="1298448"/>
+            <a:ext cx="2121408" cy="219456"/>
           </a:xfrm>
           <a:prstGeom prst="rect">
             <a:avLst/>
@@ -12893,21 +14337,21 @@
                 </a:solidFill>
                 <a:latin typeface="Segoe UI"/>
               </a:rPr>
-              <a:t>Q4 2026</a:t>
-            </a:r>
-          </a:p>
-        </p:txBody>
-      </p:sp>
-      <p:sp>
-        <p:nvSpPr>
-          <p:cNvPr id="18" name="TextBox 17"/>
-          <p:cNvSpPr txBox="1"/>
-          <p:nvPr/>
-        </p:nvSpPr>
-        <p:spPr>
-          <a:xfrm>
-            <a:off x="2788920" y="2029968"/>
-            <a:ext cx="2121408" cy="182880"/>
+              <a:t>Q2 2027</a:t>
+            </a:r>
+          </a:p>
+        </p:txBody>
+      </p:sp>
+      <p:sp>
+        <p:nvSpPr>
+          <p:cNvPr id="57" name="TextBox 56"/>
+          <p:cNvSpPr txBox="1"/>
+          <p:nvPr/>
+        </p:nvSpPr>
+        <p:spPr>
+          <a:xfrm>
+            <a:off x="7269479" y="1508760"/>
+            <a:ext cx="2121408" cy="164592"/>
           </a:xfrm>
           <a:prstGeom prst="rect">
             <a:avLst/>
@@ -12932,20 +14376,20 @@
                 </a:solidFill>
                 <a:latin typeface="Segoe UI"/>
               </a:rPr>
-              <a:t>LOGS &amp; AGENTS</a:t>
-            </a:r>
-          </a:p>
-        </p:txBody>
-      </p:sp>
-      <p:sp>
-        <p:nvSpPr>
-          <p:cNvPr id="19" name="Rectangle 18"/>
+              <a:t>ASSURANCE</a:t>
+            </a:r>
+          </a:p>
+        </p:txBody>
+      </p:sp>
+      <p:sp>
+        <p:nvSpPr>
+          <p:cNvPr id="58" name="Rectangle 57"/>
           <p:cNvSpPr/>
           <p:nvPr/>
         </p:nvSpPr>
         <p:spPr>
           <a:xfrm>
-            <a:off x="2788920" y="2212848"/>
+            <a:off x="7269479" y="1700784"/>
             <a:ext cx="457200" cy="25603"/>
           </a:xfrm>
           <a:prstGeom prst="rect">
@@ -12983,24 +14427,26 @@
       </p:sp>
       <p:sp>
         <p:nvSpPr>
-          <p:cNvPr id="20" name="Rectangle 19"/>
+          <p:cNvPr id="59" name="Rounded Rectangle 58"/>
           <p:cNvSpPr/>
           <p:nvPr/>
         </p:nvSpPr>
         <p:spPr>
           <a:xfrm>
-            <a:off x="2788920" y="2395728"/>
-            <a:ext cx="2121408" cy="1060704"/>
-          </a:xfrm>
-          <a:prstGeom prst="rect">
-            <a:avLst/>
+            <a:off x="7269479" y="1828800"/>
+            <a:ext cx="2121408" cy="1298448"/>
+          </a:xfrm>
+          <a:prstGeom prst="roundRect">
+            <a:avLst>
+              <a:gd name="adj" fmla="val 9000"/>
+            </a:avLst>
           </a:prstGeom>
           <a:solidFill>
             <a:srgbClr val="FFFFFF"/>
           </a:solidFill>
           <a:ln w="9525">
             <a:solidFill>
-              <a:srgbClr val="D8DCE1"/>
+              <a:srgbClr val="E1E6EF"/>
             </a:solidFill>
           </a:ln>
           <a:effectLst/>
@@ -13027,16 +14473,616 @@
           </a:p>
         </p:txBody>
       </p:sp>
-      <p:sp>
-        <p:nvSpPr>
-          <p:cNvPr id="21" name="Rectangle 20"/>
+      <p:pic>
+        <p:nvPicPr>
+          <p:cNvPr id="60" name="Picture 59" descr="observability-score.png"/>
+          <p:cNvPicPr>
+            <a:picLocks noChangeAspect="1"/>
+          </p:cNvPicPr>
+          <p:nvPr/>
+        </p:nvPicPr>
+        <p:blipFill>
+          <a:blip r:embed="rId10"/>
+          <a:stretch>
+            <a:fillRect/>
+          </a:stretch>
+        </p:blipFill>
+        <p:spPr>
+          <a:xfrm>
+            <a:off x="7397496" y="1947672"/>
+            <a:ext cx="329184" cy="329184"/>
+          </a:xfrm>
+          <a:prstGeom prst="rect">
+            <a:avLst/>
+          </a:prstGeom>
+          <a:effectLst/>
+        </p:spPr>
+      </p:pic>
+      <p:sp>
+        <p:nvSpPr>
+          <p:cNvPr id="61" name="TextBox 60"/>
+          <p:cNvSpPr txBox="1"/>
+          <p:nvPr/>
+        </p:nvSpPr>
+        <p:spPr>
+          <a:xfrm>
+            <a:off x="7397496" y="2350008"/>
+            <a:ext cx="1865376" cy="219456"/>
+          </a:xfrm>
+          <a:prstGeom prst="rect">
+            <a:avLst/>
+          </a:prstGeom>
+          <a:noFill/>
+        </p:spPr>
+        <p:txBody>
+          <a:bodyPr wrap="square" anchor="t" lIns="0" rIns="0" tIns="0" bIns="0">
+            <a:spAutoFit/>
+          </a:bodyPr>
+          <a:lstStyle/>
+          <a:p>
+            <a:pPr algn="l">
+              <a:spcAft>
+                <a:spcPts val="0"/>
+              </a:spcAft>
+            </a:pPr>
+            <a:r>
+              <a:rPr sz="950" b="1">
+                <a:solidFill>
+                  <a:srgbClr val="10182B"/>
+                </a:solidFill>
+                <a:latin typeface="Segoe UI"/>
+              </a:rPr>
+              <a:t>Observability Score</a:t>
+            </a:r>
+          </a:p>
+        </p:txBody>
+      </p:sp>
+      <p:sp>
+        <p:nvSpPr>
+          <p:cNvPr id="62" name="TextBox 61"/>
+          <p:cNvSpPr txBox="1"/>
+          <p:nvPr/>
+        </p:nvSpPr>
+        <p:spPr>
+          <a:xfrm>
+            <a:off x="7397496" y="2560320"/>
+            <a:ext cx="1865376" cy="310896"/>
+          </a:xfrm>
+          <a:prstGeom prst="rect">
+            <a:avLst/>
+          </a:prstGeom>
+          <a:noFill/>
+        </p:spPr>
+        <p:txBody>
+          <a:bodyPr wrap="square" anchor="t" lIns="0" rIns="0" tIns="0" bIns="0">
+            <a:spAutoFit/>
+          </a:bodyPr>
+          <a:lstStyle/>
+          <a:p>
+            <a:pPr algn="l">
+              <a:spcAft>
+                <a:spcPts val="0"/>
+              </a:spcAft>
+            </a:pPr>
+            <a:r>
+              <a:rPr sz="750" b="0">
+                <a:solidFill>
+                  <a:srgbClr val="55637D"/>
+                </a:solidFill>
+                <a:latin typeface="Segoe UI"/>
+              </a:rPr>
+              <a:t>Scorecard &amp; certification per asset</a:t>
+            </a:r>
+          </a:p>
+        </p:txBody>
+      </p:sp>
+      <p:sp>
+        <p:nvSpPr>
+          <p:cNvPr id="63" name="TextBox 62"/>
+          <p:cNvSpPr txBox="1"/>
+          <p:nvPr/>
+        </p:nvSpPr>
+        <p:spPr>
+          <a:xfrm>
+            <a:off x="7397496" y="2907791"/>
+            <a:ext cx="1865376" cy="182880"/>
+          </a:xfrm>
+          <a:prstGeom prst="rect">
+            <a:avLst/>
+          </a:prstGeom>
+          <a:noFill/>
+        </p:spPr>
+        <p:txBody>
+          <a:bodyPr wrap="square" anchor="t" lIns="0" rIns="0" tIns="0" bIns="0">
+            <a:spAutoFit/>
+          </a:bodyPr>
+          <a:lstStyle/>
+          <a:p>
+            <a:pPr algn="l">
+              <a:spcAft>
+                <a:spcPts val="0"/>
+              </a:spcAft>
+            </a:pPr>
+            <a:r>
+              <a:rPr sz="750" b="1">
+                <a:solidFill>
+                  <a:srgbClr val="F59300"/>
+                </a:solidFill>
+                <a:latin typeface="Segoe UI"/>
+              </a:rPr>
+              <a:t>View scorecard  →</a:t>
+            </a:r>
+          </a:p>
+        </p:txBody>
+      </p:sp>
+      <p:sp>
+        <p:nvSpPr>
+          <p:cNvPr id="64" name="Rounded Rectangle 63"/>
           <p:cNvSpPr/>
           <p:nvPr/>
         </p:nvSpPr>
         <p:spPr>
           <a:xfrm>
-            <a:off x="2788920" y="2395728"/>
-            <a:ext cx="2121408" cy="36576"/>
+            <a:off x="7269479" y="3255264"/>
+            <a:ext cx="2121408" cy="1298448"/>
+          </a:xfrm>
+          <a:prstGeom prst="roundRect">
+            <a:avLst>
+              <a:gd name="adj" fmla="val 9000"/>
+            </a:avLst>
+          </a:prstGeom>
+          <a:solidFill>
+            <a:srgbClr val="FFFFFF"/>
+          </a:solidFill>
+          <a:ln w="9525">
+            <a:solidFill>
+              <a:srgbClr val="E1E6EF"/>
+            </a:solidFill>
+          </a:ln>
+          <a:effectLst/>
+        </p:spPr>
+        <p:style>
+          <a:lnRef idx="1">
+            <a:schemeClr val="accent1"/>
+          </a:lnRef>
+          <a:fillRef idx="3">
+            <a:schemeClr val="accent1"/>
+          </a:fillRef>
+          <a:effectRef idx="2">
+            <a:schemeClr val="accent1"/>
+          </a:effectRef>
+          <a:fontRef idx="minor">
+            <a:schemeClr val="lt1"/>
+          </a:fontRef>
+        </p:style>
+        <p:txBody>
+          <a:bodyPr rtlCol="0" anchor="ctr"/>
+          <a:lstStyle/>
+          <a:p>
+            <a:pPr algn="ctr"/>
+          </a:p>
+        </p:txBody>
+      </p:sp>
+      <p:pic>
+        <p:nvPicPr>
+          <p:cNvPr id="65" name="Picture 64" descr="synthetic-alerting.png"/>
+          <p:cNvPicPr>
+            <a:picLocks noChangeAspect="1"/>
+          </p:cNvPicPr>
+          <p:nvPr/>
+        </p:nvPicPr>
+        <p:blipFill>
+          <a:blip r:embed="rId11"/>
+          <a:stretch>
+            <a:fillRect/>
+          </a:stretch>
+        </p:blipFill>
+        <p:spPr>
+          <a:xfrm>
+            <a:off x="7397496" y="3374136"/>
+            <a:ext cx="329184" cy="329184"/>
+          </a:xfrm>
+          <a:prstGeom prst="rect">
+            <a:avLst/>
+          </a:prstGeom>
+          <a:effectLst/>
+        </p:spPr>
+      </p:pic>
+      <p:sp>
+        <p:nvSpPr>
+          <p:cNvPr id="66" name="TextBox 65"/>
+          <p:cNvSpPr txBox="1"/>
+          <p:nvPr/>
+        </p:nvSpPr>
+        <p:spPr>
+          <a:xfrm>
+            <a:off x="7397496" y="3776472"/>
+            <a:ext cx="1865376" cy="219456"/>
+          </a:xfrm>
+          <a:prstGeom prst="rect">
+            <a:avLst/>
+          </a:prstGeom>
+          <a:noFill/>
+        </p:spPr>
+        <p:txBody>
+          <a:bodyPr wrap="square" anchor="t" lIns="0" rIns="0" tIns="0" bIns="0">
+            <a:spAutoFit/>
+          </a:bodyPr>
+          <a:lstStyle/>
+          <a:p>
+            <a:pPr algn="l">
+              <a:spcAft>
+                <a:spcPts val="0"/>
+              </a:spcAft>
+            </a:pPr>
+            <a:r>
+              <a:rPr sz="950" b="1">
+                <a:solidFill>
+                  <a:srgbClr val="10182B"/>
+                </a:solidFill>
+                <a:latin typeface="Segoe UI"/>
+              </a:rPr>
+              <a:t>Synthetic Alerting</a:t>
+            </a:r>
+          </a:p>
+        </p:txBody>
+      </p:sp>
+      <p:sp>
+        <p:nvSpPr>
+          <p:cNvPr id="67" name="TextBox 66"/>
+          <p:cNvSpPr txBox="1"/>
+          <p:nvPr/>
+        </p:nvSpPr>
+        <p:spPr>
+          <a:xfrm>
+            <a:off x="7397496" y="3986784"/>
+            <a:ext cx="1865376" cy="310896"/>
+          </a:xfrm>
+          <a:prstGeom prst="rect">
+            <a:avLst/>
+          </a:prstGeom>
+          <a:noFill/>
+        </p:spPr>
+        <p:txBody>
+          <a:bodyPr wrap="square" anchor="t" lIns="0" rIns="0" tIns="0" bIns="0">
+            <a:spAutoFit/>
+          </a:bodyPr>
+          <a:lstStyle/>
+          <a:p>
+            <a:pPr algn="l">
+              <a:spcAft>
+                <a:spcPts val="0"/>
+              </a:spcAft>
+            </a:pPr>
+            <a:r>
+              <a:rPr sz="750" b="0">
+                <a:solidFill>
+                  <a:srgbClr val="55637D"/>
+                </a:solidFill>
+                <a:latin typeface="Segoe UI"/>
+              </a:rPr>
+              <a:t>End-to-end fire drills — [DRILL] ticket out</a:t>
+            </a:r>
+          </a:p>
+        </p:txBody>
+      </p:sp>
+      <p:sp>
+        <p:nvSpPr>
+          <p:cNvPr id="68" name="TextBox 67"/>
+          <p:cNvSpPr txBox="1"/>
+          <p:nvPr/>
+        </p:nvSpPr>
+        <p:spPr>
+          <a:xfrm>
+            <a:off x="7397496" y="4334256"/>
+            <a:ext cx="1865376" cy="182880"/>
+          </a:xfrm>
+          <a:prstGeom prst="rect">
+            <a:avLst/>
+          </a:prstGeom>
+          <a:noFill/>
+        </p:spPr>
+        <p:txBody>
+          <a:bodyPr wrap="square" anchor="t" lIns="0" rIns="0" tIns="0" bIns="0">
+            <a:spAutoFit/>
+          </a:bodyPr>
+          <a:lstStyle/>
+          <a:p>
+            <a:pPr algn="l">
+              <a:spcAft>
+                <a:spcPts val="0"/>
+              </a:spcAft>
+            </a:pPr>
+            <a:r>
+              <a:rPr sz="750" b="1">
+                <a:solidFill>
+                  <a:srgbClr val="CF2E8D"/>
+                </a:solidFill>
+                <a:latin typeface="Segoe UI"/>
+              </a:rPr>
+              <a:t>Run a drill  →</a:t>
+            </a:r>
+          </a:p>
+        </p:txBody>
+      </p:sp>
+      <p:sp>
+        <p:nvSpPr>
+          <p:cNvPr id="69" name="Rounded Rectangle 68"/>
+          <p:cNvSpPr/>
+          <p:nvPr/>
+        </p:nvSpPr>
+        <p:spPr>
+          <a:xfrm>
+            <a:off x="7269479" y="4681728"/>
+            <a:ext cx="2121408" cy="1298448"/>
+          </a:xfrm>
+          <a:prstGeom prst="roundRect">
+            <a:avLst>
+              <a:gd name="adj" fmla="val 9000"/>
+            </a:avLst>
+          </a:prstGeom>
+          <a:solidFill>
+            <a:srgbClr val="FFFFFF"/>
+          </a:solidFill>
+          <a:ln w="9525">
+            <a:solidFill>
+              <a:srgbClr val="E1E6EF"/>
+            </a:solidFill>
+          </a:ln>
+          <a:effectLst/>
+        </p:spPr>
+        <p:style>
+          <a:lnRef idx="1">
+            <a:schemeClr val="accent1"/>
+          </a:lnRef>
+          <a:fillRef idx="3">
+            <a:schemeClr val="accent1"/>
+          </a:fillRef>
+          <a:effectRef idx="2">
+            <a:schemeClr val="accent1"/>
+          </a:effectRef>
+          <a:fontRef idx="minor">
+            <a:schemeClr val="lt1"/>
+          </a:fontRef>
+        </p:style>
+        <p:txBody>
+          <a:bodyPr rtlCol="0" anchor="ctr"/>
+          <a:lstStyle/>
+          <a:p>
+            <a:pPr algn="ctr"/>
+          </a:p>
+        </p:txBody>
+      </p:sp>
+      <p:pic>
+        <p:nvPicPr>
+          <p:cNvPr id="70" name="Picture 69" descr="alert-suppression.png"/>
+          <p:cNvPicPr>
+            <a:picLocks noChangeAspect="1"/>
+          </p:cNvPicPr>
+          <p:nvPr/>
+        </p:nvPicPr>
+        <p:blipFill>
+          <a:blip r:embed="rId12"/>
+          <a:stretch>
+            <a:fillRect/>
+          </a:stretch>
+        </p:blipFill>
+        <p:spPr>
+          <a:xfrm>
+            <a:off x="7397496" y="4800600"/>
+            <a:ext cx="329184" cy="329184"/>
+          </a:xfrm>
+          <a:prstGeom prst="rect">
+            <a:avLst/>
+          </a:prstGeom>
+          <a:effectLst/>
+        </p:spPr>
+      </p:pic>
+      <p:sp>
+        <p:nvSpPr>
+          <p:cNvPr id="71" name="TextBox 70"/>
+          <p:cNvSpPr txBox="1"/>
+          <p:nvPr/>
+        </p:nvSpPr>
+        <p:spPr>
+          <a:xfrm>
+            <a:off x="7397496" y="5202936"/>
+            <a:ext cx="1865376" cy="219456"/>
+          </a:xfrm>
+          <a:prstGeom prst="rect">
+            <a:avLst/>
+          </a:prstGeom>
+          <a:noFill/>
+        </p:spPr>
+        <p:txBody>
+          <a:bodyPr wrap="square" anchor="t" lIns="0" rIns="0" tIns="0" bIns="0">
+            <a:spAutoFit/>
+          </a:bodyPr>
+          <a:lstStyle/>
+          <a:p>
+            <a:pPr algn="l">
+              <a:spcAft>
+                <a:spcPts val="0"/>
+              </a:spcAft>
+            </a:pPr>
+            <a:r>
+              <a:rPr sz="950" b="1">
+                <a:solidFill>
+                  <a:srgbClr val="10182B"/>
+                </a:solidFill>
+                <a:latin typeface="Segoe UI"/>
+              </a:rPr>
+              <a:t>Alert Suppression</a:t>
+            </a:r>
+          </a:p>
+        </p:txBody>
+      </p:sp>
+      <p:sp>
+        <p:nvSpPr>
+          <p:cNvPr id="72" name="TextBox 71"/>
+          <p:cNvSpPr txBox="1"/>
+          <p:nvPr/>
+        </p:nvSpPr>
+        <p:spPr>
+          <a:xfrm>
+            <a:off x="7397496" y="5413248"/>
+            <a:ext cx="1865376" cy="310896"/>
+          </a:xfrm>
+          <a:prstGeom prst="rect">
+            <a:avLst/>
+          </a:prstGeom>
+          <a:noFill/>
+        </p:spPr>
+        <p:txBody>
+          <a:bodyPr wrap="square" anchor="t" lIns="0" rIns="0" tIns="0" bIns="0">
+            <a:spAutoFit/>
+          </a:bodyPr>
+          <a:lstStyle/>
+          <a:p>
+            <a:pPr algn="l">
+              <a:spcAft>
+                <a:spcPts val="0"/>
+              </a:spcAft>
+            </a:pPr>
+            <a:r>
+              <a:rPr sz="750" b="0">
+                <a:solidFill>
+                  <a:srgbClr val="55637D"/>
+                </a:solidFill>
+                <a:latin typeface="Segoe UI"/>
+              </a:rPr>
+              <a:t>Governed change windows, auto-expiring</a:t>
+            </a:r>
+          </a:p>
+        </p:txBody>
+      </p:sp>
+      <p:sp>
+        <p:nvSpPr>
+          <p:cNvPr id="73" name="TextBox 72"/>
+          <p:cNvSpPr txBox="1"/>
+          <p:nvPr/>
+        </p:nvSpPr>
+        <p:spPr>
+          <a:xfrm>
+            <a:off x="7397496" y="5760720"/>
+            <a:ext cx="1865376" cy="182880"/>
+          </a:xfrm>
+          <a:prstGeom prst="rect">
+            <a:avLst/>
+          </a:prstGeom>
+          <a:noFill/>
+        </p:spPr>
+        <p:txBody>
+          <a:bodyPr wrap="square" anchor="t" lIns="0" rIns="0" tIns="0" bIns="0">
+            <a:spAutoFit/>
+          </a:bodyPr>
+          <a:lstStyle/>
+          <a:p>
+            <a:pPr algn="l">
+              <a:spcAft>
+                <a:spcPts val="0"/>
+              </a:spcAft>
+            </a:pPr>
+            <a:r>
+              <a:rPr sz="750" b="1">
+                <a:solidFill>
+                  <a:srgbClr val="1D9F5F"/>
+                </a:solidFill>
+                <a:latin typeface="Segoe UI"/>
+              </a:rPr>
+              <a:t>Schedule window  →</a:t>
+            </a:r>
+          </a:p>
+        </p:txBody>
+      </p:sp>
+      <p:sp>
+        <p:nvSpPr>
+          <p:cNvPr id="74" name="TextBox 73"/>
+          <p:cNvSpPr txBox="1"/>
+          <p:nvPr/>
+        </p:nvSpPr>
+        <p:spPr>
+          <a:xfrm>
+            <a:off x="9509759" y="1298448"/>
+            <a:ext cx="2121408" cy="219456"/>
+          </a:xfrm>
+          <a:prstGeom prst="rect">
+            <a:avLst/>
+          </a:prstGeom>
+          <a:noFill/>
+        </p:spPr>
+        <p:txBody>
+          <a:bodyPr wrap="square" anchor="t" lIns="0" rIns="0" tIns="0" bIns="0">
+            <a:spAutoFit/>
+          </a:bodyPr>
+          <a:lstStyle/>
+          <a:p>
+            <a:pPr algn="l">
+              <a:spcAft>
+                <a:spcPts val="400"/>
+              </a:spcAft>
+            </a:pPr>
+            <a:r>
+              <a:rPr sz="1100" b="1">
+                <a:solidFill>
+                  <a:srgbClr val="2E74B5"/>
+                </a:solidFill>
+                <a:latin typeface="Segoe UI"/>
+              </a:rPr>
+              <a:t>H2 2027</a:t>
+            </a:r>
+          </a:p>
+        </p:txBody>
+      </p:sp>
+      <p:sp>
+        <p:nvSpPr>
+          <p:cNvPr id="75" name="TextBox 74"/>
+          <p:cNvSpPr txBox="1"/>
+          <p:nvPr/>
+        </p:nvSpPr>
+        <p:spPr>
+          <a:xfrm>
+            <a:off x="9509759" y="1508760"/>
+            <a:ext cx="2121408" cy="164592"/>
+          </a:xfrm>
+          <a:prstGeom prst="rect">
+            <a:avLst/>
+          </a:prstGeom>
+          <a:noFill/>
+        </p:spPr>
+        <p:txBody>
+          <a:bodyPr wrap="square" anchor="t" lIns="0" rIns="0" tIns="0" bIns="0">
+            <a:spAutoFit/>
+          </a:bodyPr>
+          <a:lstStyle/>
+          <a:p>
+            <a:pPr algn="l">
+              <a:spcAft>
+                <a:spcPts val="400"/>
+              </a:spcAft>
+            </a:pPr>
+            <a:r>
+              <a:rPr sz="800" b="1">
+                <a:solidFill>
+                  <a:srgbClr val="7A808A"/>
+                </a:solidFill>
+                <a:latin typeface="Segoe UI"/>
+              </a:rPr>
+              <a:t>INTELLIGENCE</a:t>
+            </a:r>
+          </a:p>
+        </p:txBody>
+      </p:sp>
+      <p:sp>
+        <p:nvSpPr>
+          <p:cNvPr id="76" name="Rectangle 75"/>
+          <p:cNvSpPr/>
+          <p:nvPr/>
+        </p:nvSpPr>
+        <p:spPr>
+          <a:xfrm>
+            <a:off x="9509759" y="1700784"/>
+            <a:ext cx="457200" cy="25603"/>
           </a:xfrm>
           <a:prstGeom prst="rect">
             <a:avLst/>
@@ -13073,79 +15119,26 @@
       </p:sp>
       <p:sp>
         <p:nvSpPr>
-          <p:cNvPr id="22" name="TextBox 21"/>
-          <p:cNvSpPr txBox="1"/>
-          <p:nvPr/>
-        </p:nvSpPr>
-        <p:spPr>
-          <a:xfrm>
-            <a:off x="2916936" y="2505456"/>
-            <a:ext cx="1865376" cy="859536"/>
-          </a:xfrm>
-          <a:prstGeom prst="rect">
-            <a:avLst/>
-          </a:prstGeom>
-          <a:noFill/>
-        </p:spPr>
-        <p:txBody>
-          <a:bodyPr wrap="square" anchor="t" lIns="0" rIns="0" tIns="0" bIns="0">
-            <a:spAutoFit/>
-          </a:bodyPr>
-          <a:lstStyle/>
-          <a:p>
-            <a:pPr algn="l">
-              <a:spcAft>
-                <a:spcPts val="200"/>
-              </a:spcAft>
-            </a:pPr>
-            <a:r>
-              <a:rPr sz="1000" b="1">
-                <a:solidFill>
-                  <a:srgbClr val="1B2A41"/>
-                </a:solidFill>
-                <a:latin typeface="Segoe UI"/>
-              </a:rPr>
-              <a:t>ELK Log Onboarding</a:t>
-            </a:r>
-          </a:p>
-          <a:p>
-            <a:pPr algn="l">
-              <a:spcAft>
-                <a:spcPts val="200"/>
-              </a:spcAft>
-            </a:pPr>
-            <a:r>
-              <a:rPr sz="800" b="0">
-                <a:solidFill>
-                  <a:srgbClr val="40444B"/>
-                </a:solidFill>
-                <a:latin typeface="Segoe UI"/>
-              </a:rPr>
-              <a:t>Agents, Kafka topic, parsers, indices — one request, one review</a:t>
-            </a:r>
-          </a:p>
-        </p:txBody>
-      </p:sp>
-      <p:sp>
-        <p:nvSpPr>
-          <p:cNvPr id="23" name="Rectangle 22"/>
+          <p:cNvPr id="77" name="Rounded Rectangle 76"/>
           <p:cNvSpPr/>
           <p:nvPr/>
         </p:nvSpPr>
         <p:spPr>
           <a:xfrm>
-            <a:off x="2788920" y="3584448"/>
-            <a:ext cx="2121408" cy="1060704"/>
-          </a:xfrm>
-          <a:prstGeom prst="rect">
-            <a:avLst/>
+            <a:off x="9509759" y="1828800"/>
+            <a:ext cx="2121408" cy="1298448"/>
+          </a:xfrm>
+          <a:prstGeom prst="roundRect">
+            <a:avLst>
+              <a:gd name="adj" fmla="val 9000"/>
+            </a:avLst>
           </a:prstGeom>
           <a:solidFill>
             <a:srgbClr val="FFFFFF"/>
           </a:solidFill>
           <a:ln w="9525">
             <a:solidFill>
-              <a:srgbClr val="D8DCE1"/>
+              <a:srgbClr val="E1E6EF"/>
             </a:solidFill>
           </a:ln>
           <a:effectLst/>
@@ -13172,1636 +15165,199 @@
           </a:p>
         </p:txBody>
       </p:sp>
-      <p:sp>
-        <p:nvSpPr>
-          <p:cNvPr id="24" name="Rectangle 23"/>
-          <p:cNvSpPr/>
-          <p:nvPr/>
-        </p:nvSpPr>
-        <p:spPr>
-          <a:xfrm>
-            <a:off x="2788920" y="3584448"/>
-            <a:ext cx="2121408" cy="36576"/>
-          </a:xfrm>
-          <a:prstGeom prst="rect">
-            <a:avLst/>
-          </a:prstGeom>
-          <a:solidFill>
-            <a:srgbClr val="2E74B5"/>
-          </a:solidFill>
-          <a:ln>
-            <a:noFill/>
-          </a:ln>
+      <p:pic>
+        <p:nvPicPr>
+          <p:cNvPr id="78" name="Picture 77" descr="observability-brain.png"/>
+          <p:cNvPicPr>
+            <a:picLocks noChangeAspect="1"/>
+          </p:cNvPicPr>
+          <p:nvPr/>
+        </p:nvPicPr>
+        <p:blipFill>
+          <a:blip r:embed="rId13"/>
+          <a:stretch>
+            <a:fillRect/>
+          </a:stretch>
+        </p:blipFill>
+        <p:spPr>
+          <a:xfrm>
+            <a:off x="9637776" y="1947672"/>
+            <a:ext cx="329184" cy="329184"/>
+          </a:xfrm>
+          <a:prstGeom prst="rect">
+            <a:avLst/>
+          </a:prstGeom>
           <a:effectLst/>
         </p:spPr>
-        <p:style>
-          <a:lnRef idx="1">
-            <a:schemeClr val="accent1"/>
-          </a:lnRef>
-          <a:fillRef idx="3">
-            <a:schemeClr val="accent1"/>
-          </a:fillRef>
-          <a:effectRef idx="2">
-            <a:schemeClr val="accent1"/>
-          </a:effectRef>
-          <a:fontRef idx="minor">
-            <a:schemeClr val="lt1"/>
-          </a:fontRef>
-        </p:style>
-        <p:txBody>
-          <a:bodyPr rtlCol="0" anchor="ctr"/>
-          <a:lstStyle/>
-          <a:p>
-            <a:pPr algn="ctr"/>
-          </a:p>
-        </p:txBody>
-      </p:sp>
-      <p:sp>
-        <p:nvSpPr>
-          <p:cNvPr id="25" name="TextBox 24"/>
-          <p:cNvSpPr txBox="1"/>
-          <p:nvPr/>
-        </p:nvSpPr>
-        <p:spPr>
-          <a:xfrm>
-            <a:off x="2916936" y="3694176"/>
-            <a:ext cx="1865376" cy="859536"/>
-          </a:xfrm>
-          <a:prstGeom prst="rect">
-            <a:avLst/>
-          </a:prstGeom>
-          <a:noFill/>
-        </p:spPr>
-        <p:txBody>
-          <a:bodyPr wrap="square" anchor="t" lIns="0" rIns="0" tIns="0" bIns="0">
-            <a:spAutoFit/>
-          </a:bodyPr>
-          <a:lstStyle/>
-          <a:p>
-            <a:pPr algn="l">
-              <a:spcAft>
-                <a:spcPts val="200"/>
-              </a:spcAft>
-            </a:pPr>
-            <a:r>
-              <a:rPr sz="1000" b="1">
+      </p:pic>
+      <p:sp>
+        <p:nvSpPr>
+          <p:cNvPr id="79" name="TextBox 78"/>
+          <p:cNvSpPr txBox="1"/>
+          <p:nvPr/>
+        </p:nvSpPr>
+        <p:spPr>
+          <a:xfrm>
+            <a:off x="9637776" y="2350008"/>
+            <a:ext cx="1865376" cy="219456"/>
+          </a:xfrm>
+          <a:prstGeom prst="rect">
+            <a:avLst/>
+          </a:prstGeom>
+          <a:noFill/>
+        </p:spPr>
+        <p:txBody>
+          <a:bodyPr wrap="square" anchor="t" lIns="0" rIns="0" tIns="0" bIns="0">
+            <a:spAutoFit/>
+          </a:bodyPr>
+          <a:lstStyle/>
+          <a:p>
+            <a:pPr algn="l">
+              <a:spcAft>
+                <a:spcPts val="0"/>
+              </a:spcAft>
+            </a:pPr>
+            <a:r>
+              <a:rPr sz="950" b="1">
+                <a:solidFill>
+                  <a:srgbClr val="10182B"/>
+                </a:solidFill>
+                <a:latin typeface="Segoe UI"/>
+              </a:rPr>
+              <a:t>Observability Brain</a:t>
+            </a:r>
+          </a:p>
+        </p:txBody>
+      </p:sp>
+      <p:sp>
+        <p:nvSpPr>
+          <p:cNvPr id="80" name="TextBox 79"/>
+          <p:cNvSpPr txBox="1"/>
+          <p:nvPr/>
+        </p:nvSpPr>
+        <p:spPr>
+          <a:xfrm>
+            <a:off x="9637776" y="2560320"/>
+            <a:ext cx="1865376" cy="310896"/>
+          </a:xfrm>
+          <a:prstGeom prst="rect">
+            <a:avLst/>
+          </a:prstGeom>
+          <a:noFill/>
+        </p:spPr>
+        <p:txBody>
+          <a:bodyPr wrap="square" anchor="t" lIns="0" rIns="0" tIns="0" bIns="0">
+            <a:spAutoFit/>
+          </a:bodyPr>
+          <a:lstStyle/>
+          <a:p>
+            <a:pPr algn="l">
+              <a:spcAft>
+                <a:spcPts val="0"/>
+              </a:spcAft>
+            </a:pPr>
+            <a:r>
+              <a:rPr sz="750" b="0">
+                <a:solidFill>
+                  <a:srgbClr val="55637D"/>
+                </a:solidFill>
+                <a:latin typeface="Segoe UI"/>
+              </a:rPr>
+              <a:t>The oracle — grounded answers over the second brain</a:t>
+            </a:r>
+          </a:p>
+        </p:txBody>
+      </p:sp>
+      <p:sp>
+        <p:nvSpPr>
+          <p:cNvPr id="81" name="TextBox 80"/>
+          <p:cNvSpPr txBox="1"/>
+          <p:nvPr/>
+        </p:nvSpPr>
+        <p:spPr>
+          <a:xfrm>
+            <a:off x="9637776" y="2907791"/>
+            <a:ext cx="1865376" cy="182880"/>
+          </a:xfrm>
+          <a:prstGeom prst="rect">
+            <a:avLst/>
+          </a:prstGeom>
+          <a:noFill/>
+        </p:spPr>
+        <p:txBody>
+          <a:bodyPr wrap="square" anchor="t" lIns="0" rIns="0" tIns="0" bIns="0">
+            <a:spAutoFit/>
+          </a:bodyPr>
+          <a:lstStyle/>
+          <a:p>
+            <a:pPr algn="l">
+              <a:spcAft>
+                <a:spcPts val="0"/>
+              </a:spcAft>
+            </a:pPr>
+            <a:r>
+              <a:rPr sz="750" b="1">
+                <a:solidFill>
+                  <a:srgbClr val="6938F2"/>
+                </a:solidFill>
+                <a:latin typeface="Segoe UI"/>
+              </a:rPr>
+              <a:t>Ask the Brain  →</a:t>
+            </a:r>
+          </a:p>
+        </p:txBody>
+      </p:sp>
+      <p:sp>
+        <p:nvSpPr>
+          <p:cNvPr id="82" name="TextBox 81"/>
+          <p:cNvSpPr txBox="1"/>
+          <p:nvPr/>
+        </p:nvSpPr>
+        <p:spPr>
+          <a:xfrm>
+            <a:off x="548640" y="6172200"/>
+            <a:ext cx="11064240" cy="320040"/>
+          </a:xfrm>
+          <a:prstGeom prst="rect">
+            <a:avLst/>
+          </a:prstGeom>
+          <a:noFill/>
+        </p:spPr>
+        <p:txBody>
+          <a:bodyPr wrap="square" anchor="t" lIns="0" rIns="0" tIns="0" bIns="0">
+            <a:spAutoFit/>
+          </a:bodyPr>
+          <a:lstStyle/>
+          <a:p>
+            <a:pPr algn="l">
+              <a:spcAft>
+                <a:spcPts val="0"/>
+              </a:spcAft>
+            </a:pPr>
+            <a:r>
+              <a:rPr sz="900" b="1">
                 <a:solidFill>
                   <a:srgbClr val="1B2A41"/>
                 </a:solidFill>
                 <a:latin typeface="Segoe UI"/>
               </a:rPr>
-              <a:t>Install Agent</a:t>
-            </a:r>
-          </a:p>
-          <a:p>
-            <a:pPr algn="l">
-              <a:spcAft>
-                <a:spcPts val="200"/>
-              </a:spcAft>
-            </a:pPr>
-            <a:r>
-              <a:rPr sz="800" b="0">
+              <a:t>Eleven services, one design language — all designed and demoable today; the roadmap is activation order. </a:t>
+            </a:r>
+            <a:r>
+              <a:rPr sz="850" b="0">
                 <a:solidFill>
                   <a:srgbClr val="40444B"/>
                 </a:solidFill>
                 <a:latin typeface="Segoe UI"/>
               </a:rPr>
-              <a:t>The right agents per host — ELK, DX UIM, OTel; only what is missing</a:t>
-            </a:r>
-          </a:p>
-        </p:txBody>
-      </p:sp>
-      <p:sp>
-        <p:nvSpPr>
-          <p:cNvPr id="26" name="Rectangle 25"/>
-          <p:cNvSpPr/>
-          <p:nvPr/>
-        </p:nvSpPr>
-        <p:spPr>
-          <a:xfrm>
-            <a:off x="2788920" y="4773168"/>
-            <a:ext cx="2121408" cy="1060704"/>
-          </a:xfrm>
-          <a:prstGeom prst="rect">
-            <a:avLst/>
-          </a:prstGeom>
-          <a:solidFill>
-            <a:srgbClr val="FFFFFF"/>
-          </a:solidFill>
-          <a:ln w="9525">
-            <a:solidFill>
-              <a:srgbClr val="D8DCE1"/>
-            </a:solidFill>
-          </a:ln>
-          <a:effectLst/>
-        </p:spPr>
-        <p:style>
-          <a:lnRef idx="1">
-            <a:schemeClr val="accent1"/>
-          </a:lnRef>
-          <a:fillRef idx="3">
-            <a:schemeClr val="accent1"/>
-          </a:fillRef>
-          <a:effectRef idx="2">
-            <a:schemeClr val="accent1"/>
-          </a:effectRef>
-          <a:fontRef idx="minor">
-            <a:schemeClr val="lt1"/>
-          </a:fontRef>
-        </p:style>
-        <p:txBody>
-          <a:bodyPr rtlCol="0" anchor="ctr"/>
-          <a:lstStyle/>
-          <a:p>
-            <a:pPr algn="ctr"/>
-          </a:p>
-        </p:txBody>
-      </p:sp>
-      <p:sp>
-        <p:nvSpPr>
-          <p:cNvPr id="27" name="Rectangle 26"/>
-          <p:cNvSpPr/>
-          <p:nvPr/>
-        </p:nvSpPr>
-        <p:spPr>
-          <a:xfrm>
-            <a:off x="2788920" y="4773168"/>
-            <a:ext cx="2121408" cy="36576"/>
-          </a:xfrm>
-          <a:prstGeom prst="rect">
-            <a:avLst/>
-          </a:prstGeom>
-          <a:solidFill>
-            <a:srgbClr val="2E74B5"/>
-          </a:solidFill>
-          <a:ln>
-            <a:noFill/>
-          </a:ln>
-          <a:effectLst/>
-        </p:spPr>
-        <p:style>
-          <a:lnRef idx="1">
-            <a:schemeClr val="accent1"/>
-          </a:lnRef>
-          <a:fillRef idx="3">
-            <a:schemeClr val="accent1"/>
-          </a:fillRef>
-          <a:effectRef idx="2">
-            <a:schemeClr val="accent1"/>
-          </a:effectRef>
-          <a:fontRef idx="minor">
-            <a:schemeClr val="lt1"/>
-          </a:fontRef>
-        </p:style>
-        <p:txBody>
-          <a:bodyPr rtlCol="0" anchor="ctr"/>
-          <a:lstStyle/>
-          <a:p>
-            <a:pPr algn="ctr"/>
-          </a:p>
-        </p:txBody>
-      </p:sp>
-      <p:sp>
-        <p:nvSpPr>
-          <p:cNvPr id="28" name="TextBox 27"/>
-          <p:cNvSpPr txBox="1"/>
-          <p:nvPr/>
-        </p:nvSpPr>
-        <p:spPr>
-          <a:xfrm>
-            <a:off x="2916936" y="4882896"/>
-            <a:ext cx="1865376" cy="859536"/>
-          </a:xfrm>
-          <a:prstGeom prst="rect">
-            <a:avLst/>
-          </a:prstGeom>
-          <a:noFill/>
-        </p:spPr>
-        <p:txBody>
-          <a:bodyPr wrap="square" anchor="t" lIns="0" rIns="0" tIns="0" bIns="0">
-            <a:spAutoFit/>
-          </a:bodyPr>
-          <a:lstStyle/>
-          <a:p>
-            <a:pPr algn="l">
-              <a:spcAft>
-                <a:spcPts val="200"/>
-              </a:spcAft>
-            </a:pPr>
-            <a:r>
-              <a:rPr sz="1000" b="1">
-                <a:solidFill>
-                  <a:srgbClr val="1B2A41"/>
-                </a:solidFill>
-                <a:latin typeface="Segoe UI"/>
-              </a:rPr>
-              <a:t>Request Log Access</a:t>
-            </a:r>
-          </a:p>
-          <a:p>
-            <a:pPr algn="l">
-              <a:spcAft>
-                <a:spcPts val="200"/>
-              </a:spcAft>
-            </a:pPr>
-            <a:r>
-              <a:rPr sz="800" b="0">
-                <a:solidFill>
-                  <a:srgbClr val="40444B"/>
-                </a:solidFill>
-                <a:latin typeface="Segoe UI"/>
-              </a:rPr>
-              <a:t>Read-only ELK index access — see what each index holds</a:t>
-            </a:r>
-          </a:p>
-        </p:txBody>
-      </p:sp>
-      <p:sp>
-        <p:nvSpPr>
-          <p:cNvPr id="29" name="TextBox 28"/>
-          <p:cNvSpPr txBox="1"/>
-          <p:nvPr/>
-        </p:nvSpPr>
-        <p:spPr>
-          <a:xfrm>
-            <a:off x="5029199" y="1810512"/>
-            <a:ext cx="2121408" cy="237744"/>
-          </a:xfrm>
-          <a:prstGeom prst="rect">
-            <a:avLst/>
-          </a:prstGeom>
-          <a:noFill/>
-        </p:spPr>
-        <p:txBody>
-          <a:bodyPr wrap="square" anchor="t" lIns="0" rIns="0" tIns="0" bIns="0">
-            <a:spAutoFit/>
-          </a:bodyPr>
-          <a:lstStyle/>
-          <a:p>
-            <a:pPr algn="l">
-              <a:spcAft>
-                <a:spcPts val="400"/>
-              </a:spcAft>
-            </a:pPr>
-            <a:r>
-              <a:rPr sz="1100" b="1">
-                <a:solidFill>
-                  <a:srgbClr val="2E74B5"/>
-                </a:solidFill>
-                <a:latin typeface="Segoe UI"/>
-              </a:rPr>
-              <a:t>Q1 2027</a:t>
-            </a:r>
-          </a:p>
-        </p:txBody>
-      </p:sp>
-      <p:sp>
-        <p:nvSpPr>
-          <p:cNvPr id="30" name="TextBox 29"/>
-          <p:cNvSpPr txBox="1"/>
-          <p:nvPr/>
-        </p:nvSpPr>
-        <p:spPr>
-          <a:xfrm>
-            <a:off x="5029199" y="2029968"/>
-            <a:ext cx="2121408" cy="182880"/>
-          </a:xfrm>
-          <a:prstGeom prst="rect">
-            <a:avLst/>
-          </a:prstGeom>
-          <a:noFill/>
-        </p:spPr>
-        <p:txBody>
-          <a:bodyPr wrap="square" anchor="t" lIns="0" rIns="0" tIns="0" bIns="0">
-            <a:spAutoFit/>
-          </a:bodyPr>
-          <a:lstStyle/>
-          <a:p>
-            <a:pPr algn="l">
-              <a:spcAft>
-                <a:spcPts val="400"/>
-              </a:spcAft>
-            </a:pPr>
-            <a:r>
-              <a:rPr sz="800" b="1">
-                <a:solidFill>
-                  <a:srgbClr val="7A808A"/>
-                </a:solidFill>
-                <a:latin typeface="Segoe UI"/>
-              </a:rPr>
-              <a:t>VISIBILITY</a:t>
-            </a:r>
-          </a:p>
-        </p:txBody>
-      </p:sp>
-      <p:sp>
-        <p:nvSpPr>
-          <p:cNvPr id="31" name="Rectangle 30"/>
-          <p:cNvSpPr/>
-          <p:nvPr/>
-        </p:nvSpPr>
-        <p:spPr>
-          <a:xfrm>
-            <a:off x="5029199" y="2212848"/>
-            <a:ext cx="457200" cy="25603"/>
-          </a:xfrm>
-          <a:prstGeom prst="rect">
-            <a:avLst/>
-          </a:prstGeom>
-          <a:solidFill>
-            <a:srgbClr val="2E74B5"/>
-          </a:solidFill>
-          <a:ln>
-            <a:noFill/>
-          </a:ln>
-          <a:effectLst/>
-        </p:spPr>
-        <p:style>
-          <a:lnRef idx="1">
-            <a:schemeClr val="accent1"/>
-          </a:lnRef>
-          <a:fillRef idx="3">
-            <a:schemeClr val="accent1"/>
-          </a:fillRef>
-          <a:effectRef idx="2">
-            <a:schemeClr val="accent1"/>
-          </a:effectRef>
-          <a:fontRef idx="minor">
-            <a:schemeClr val="lt1"/>
-          </a:fontRef>
-        </p:style>
-        <p:txBody>
-          <a:bodyPr rtlCol="0" anchor="ctr"/>
-          <a:lstStyle/>
-          <a:p>
-            <a:pPr algn="ctr"/>
-          </a:p>
-        </p:txBody>
-      </p:sp>
-      <p:sp>
-        <p:nvSpPr>
-          <p:cNvPr id="32" name="Rectangle 31"/>
-          <p:cNvSpPr/>
-          <p:nvPr/>
-        </p:nvSpPr>
-        <p:spPr>
-          <a:xfrm>
-            <a:off x="5029199" y="2395728"/>
-            <a:ext cx="2121408" cy="1060704"/>
-          </a:xfrm>
-          <a:prstGeom prst="rect">
-            <a:avLst/>
-          </a:prstGeom>
-          <a:solidFill>
-            <a:srgbClr val="FFFFFF"/>
-          </a:solidFill>
-          <a:ln w="9525">
-            <a:solidFill>
-              <a:srgbClr val="D8DCE1"/>
-            </a:solidFill>
-          </a:ln>
-          <a:effectLst/>
-        </p:spPr>
-        <p:style>
-          <a:lnRef idx="1">
-            <a:schemeClr val="accent1"/>
-          </a:lnRef>
-          <a:fillRef idx="3">
-            <a:schemeClr val="accent1"/>
-          </a:fillRef>
-          <a:effectRef idx="2">
-            <a:schemeClr val="accent1"/>
-          </a:effectRef>
-          <a:fontRef idx="minor">
-            <a:schemeClr val="lt1"/>
-          </a:fontRef>
-        </p:style>
-        <p:txBody>
-          <a:bodyPr rtlCol="0" anchor="ctr"/>
-          <a:lstStyle/>
-          <a:p>
-            <a:pPr algn="ctr"/>
-          </a:p>
-        </p:txBody>
-      </p:sp>
-      <p:sp>
-        <p:nvSpPr>
-          <p:cNvPr id="33" name="Rectangle 32"/>
-          <p:cNvSpPr/>
-          <p:nvPr/>
-        </p:nvSpPr>
-        <p:spPr>
-          <a:xfrm>
-            <a:off x="5029199" y="2395728"/>
-            <a:ext cx="2121408" cy="36576"/>
-          </a:xfrm>
-          <a:prstGeom prst="rect">
-            <a:avLst/>
-          </a:prstGeom>
-          <a:solidFill>
-            <a:srgbClr val="2E74B5"/>
-          </a:solidFill>
-          <a:ln>
-            <a:noFill/>
-          </a:ln>
-          <a:effectLst/>
-        </p:spPr>
-        <p:style>
-          <a:lnRef idx="1">
-            <a:schemeClr val="accent1"/>
-          </a:lnRef>
-          <a:fillRef idx="3">
-            <a:schemeClr val="accent1"/>
-          </a:fillRef>
-          <a:effectRef idx="2">
-            <a:schemeClr val="accent1"/>
-          </a:effectRef>
-          <a:fontRef idx="minor">
-            <a:schemeClr val="lt1"/>
-          </a:fontRef>
-        </p:style>
-        <p:txBody>
-          <a:bodyPr rtlCol="0" anchor="ctr"/>
-          <a:lstStyle/>
-          <a:p>
-            <a:pPr algn="ctr"/>
-          </a:p>
-        </p:txBody>
-      </p:sp>
-      <p:sp>
-        <p:nvSpPr>
-          <p:cNvPr id="34" name="TextBox 33"/>
-          <p:cNvSpPr txBox="1"/>
-          <p:nvPr/>
-        </p:nvSpPr>
-        <p:spPr>
-          <a:xfrm>
-            <a:off x="5157215" y="2505456"/>
-            <a:ext cx="1865376" cy="859536"/>
-          </a:xfrm>
-          <a:prstGeom prst="rect">
-            <a:avLst/>
-          </a:prstGeom>
-          <a:noFill/>
-        </p:spPr>
-        <p:txBody>
-          <a:bodyPr wrap="square" anchor="t" lIns="0" rIns="0" tIns="0" bIns="0">
-            <a:spAutoFit/>
-          </a:bodyPr>
-          <a:lstStyle/>
-          <a:p>
-            <a:pPr algn="l">
-              <a:spcAft>
-                <a:spcPts val="200"/>
-              </a:spcAft>
-            </a:pPr>
-            <a:r>
-              <a:rPr sz="1000" b="1">
-                <a:solidFill>
-                  <a:srgbClr val="1B2A41"/>
-                </a:solidFill>
-                <a:latin typeface="Segoe UI"/>
-              </a:rPr>
-              <a:t>Reports</a:t>
-            </a:r>
-          </a:p>
-          <a:p>
-            <a:pPr algn="l">
-              <a:spcAft>
-                <a:spcPts val="200"/>
-              </a:spcAft>
-            </a:pPr>
-            <a:r>
-              <a:rPr sz="800" b="0">
-                <a:solidFill>
-                  <a:srgbClr val="40444B"/>
-                </a:solidFill>
-                <a:latin typeface="Segoe UI"/>
-              </a:rPr>
-              <a:t>Daily reconciliation — missing from ELK, unmonitored, drifted</a:t>
-            </a:r>
-          </a:p>
-        </p:txBody>
-      </p:sp>
-      <p:sp>
-        <p:nvSpPr>
-          <p:cNvPr id="35" name="Rectangle 34"/>
-          <p:cNvSpPr/>
-          <p:nvPr/>
-        </p:nvSpPr>
-        <p:spPr>
-          <a:xfrm>
-            <a:off x="5029199" y="3584448"/>
-            <a:ext cx="2121408" cy="1060704"/>
-          </a:xfrm>
-          <a:prstGeom prst="rect">
-            <a:avLst/>
-          </a:prstGeom>
-          <a:solidFill>
-            <a:srgbClr val="FFFFFF"/>
-          </a:solidFill>
-          <a:ln w="9525">
-            <a:solidFill>
-              <a:srgbClr val="D8DCE1"/>
-            </a:solidFill>
-          </a:ln>
-          <a:effectLst/>
-        </p:spPr>
-        <p:style>
-          <a:lnRef idx="1">
-            <a:schemeClr val="accent1"/>
-          </a:lnRef>
-          <a:fillRef idx="3">
-            <a:schemeClr val="accent1"/>
-          </a:fillRef>
-          <a:effectRef idx="2">
-            <a:schemeClr val="accent1"/>
-          </a:effectRef>
-          <a:fontRef idx="minor">
-            <a:schemeClr val="lt1"/>
-          </a:fontRef>
-        </p:style>
-        <p:txBody>
-          <a:bodyPr rtlCol="0" anchor="ctr"/>
-          <a:lstStyle/>
-          <a:p>
-            <a:pPr algn="ctr"/>
-          </a:p>
-        </p:txBody>
-      </p:sp>
-      <p:sp>
-        <p:nvSpPr>
-          <p:cNvPr id="36" name="Rectangle 35"/>
-          <p:cNvSpPr/>
-          <p:nvPr/>
-        </p:nvSpPr>
-        <p:spPr>
-          <a:xfrm>
-            <a:off x="5029199" y="3584448"/>
-            <a:ext cx="2121408" cy="36576"/>
-          </a:xfrm>
-          <a:prstGeom prst="rect">
-            <a:avLst/>
-          </a:prstGeom>
-          <a:solidFill>
-            <a:srgbClr val="2E74B5"/>
-          </a:solidFill>
-          <a:ln>
-            <a:noFill/>
-          </a:ln>
-          <a:effectLst/>
-        </p:spPr>
-        <p:style>
-          <a:lnRef idx="1">
-            <a:schemeClr val="accent1"/>
-          </a:lnRef>
-          <a:fillRef idx="3">
-            <a:schemeClr val="accent1"/>
-          </a:fillRef>
-          <a:effectRef idx="2">
-            <a:schemeClr val="accent1"/>
-          </a:effectRef>
-          <a:fontRef idx="minor">
-            <a:schemeClr val="lt1"/>
-          </a:fontRef>
-        </p:style>
-        <p:txBody>
-          <a:bodyPr rtlCol="0" anchor="ctr"/>
-          <a:lstStyle/>
-          <a:p>
-            <a:pPr algn="ctr"/>
-          </a:p>
-        </p:txBody>
-      </p:sp>
-      <p:sp>
-        <p:nvSpPr>
-          <p:cNvPr id="37" name="TextBox 36"/>
-          <p:cNvSpPr txBox="1"/>
-          <p:nvPr/>
-        </p:nvSpPr>
-        <p:spPr>
-          <a:xfrm>
-            <a:off x="5157215" y="3694176"/>
-            <a:ext cx="1865376" cy="859536"/>
-          </a:xfrm>
-          <a:prstGeom prst="rect">
-            <a:avLst/>
-          </a:prstGeom>
-          <a:noFill/>
-        </p:spPr>
-        <p:txBody>
-          <a:bodyPr wrap="square" anchor="t" lIns="0" rIns="0" tIns="0" bIns="0">
-            <a:spAutoFit/>
-          </a:bodyPr>
-          <a:lstStyle/>
-          <a:p>
-            <a:pPr algn="l">
-              <a:spcAft>
-                <a:spcPts val="200"/>
-              </a:spcAft>
-            </a:pPr>
-            <a:r>
-              <a:rPr sz="1000" b="1">
-                <a:solidFill>
-                  <a:srgbClr val="1B2A41"/>
-                </a:solidFill>
-                <a:latin typeface="Segoe UI"/>
-              </a:rPr>
-              <a:t>Dashboard Inventory</a:t>
-            </a:r>
-          </a:p>
-          <a:p>
-            <a:pPr algn="l">
-              <a:spcAft>
-                <a:spcPts val="200"/>
-              </a:spcAft>
-            </a:pPr>
-            <a:r>
-              <a:rPr sz="800" b="0">
-                <a:solidFill>
-                  <a:srgbClr val="40444B"/>
-                </a:solidFill>
-                <a:latin typeface="Segoe UI"/>
-              </a:rPr>
-              <a:t>Every dashboard described and linked — one page, always current</a:t>
-            </a:r>
-          </a:p>
-        </p:txBody>
-      </p:sp>
-      <p:sp>
-        <p:nvSpPr>
-          <p:cNvPr id="38" name="Rectangle 37"/>
-          <p:cNvSpPr/>
-          <p:nvPr/>
-        </p:nvSpPr>
-        <p:spPr>
-          <a:xfrm>
-            <a:off x="5029199" y="4773168"/>
-            <a:ext cx="2121408" cy="1060704"/>
-          </a:xfrm>
-          <a:prstGeom prst="rect">
-            <a:avLst/>
-          </a:prstGeom>
-          <a:solidFill>
-            <a:srgbClr val="FFFFFF"/>
-          </a:solidFill>
-          <a:ln w="9525">
-            <a:solidFill>
-              <a:srgbClr val="D8DCE1"/>
-            </a:solidFill>
-          </a:ln>
-          <a:effectLst/>
-        </p:spPr>
-        <p:style>
-          <a:lnRef idx="1">
-            <a:schemeClr val="accent1"/>
-          </a:lnRef>
-          <a:fillRef idx="3">
-            <a:schemeClr val="accent1"/>
-          </a:fillRef>
-          <a:effectRef idx="2">
-            <a:schemeClr val="accent1"/>
-          </a:effectRef>
-          <a:fontRef idx="minor">
-            <a:schemeClr val="lt1"/>
-          </a:fontRef>
-        </p:style>
-        <p:txBody>
-          <a:bodyPr rtlCol="0" anchor="ctr"/>
-          <a:lstStyle/>
-          <a:p>
-            <a:pPr algn="ctr"/>
-          </a:p>
-        </p:txBody>
-      </p:sp>
-      <p:sp>
-        <p:nvSpPr>
-          <p:cNvPr id="39" name="Rectangle 38"/>
-          <p:cNvSpPr/>
-          <p:nvPr/>
-        </p:nvSpPr>
-        <p:spPr>
-          <a:xfrm>
-            <a:off x="5029199" y="4773168"/>
-            <a:ext cx="2121408" cy="36576"/>
-          </a:xfrm>
-          <a:prstGeom prst="rect">
-            <a:avLst/>
-          </a:prstGeom>
-          <a:solidFill>
-            <a:srgbClr val="2E74B5"/>
-          </a:solidFill>
-          <a:ln>
-            <a:noFill/>
-          </a:ln>
-          <a:effectLst/>
-        </p:spPr>
-        <p:style>
-          <a:lnRef idx="1">
-            <a:schemeClr val="accent1"/>
-          </a:lnRef>
-          <a:fillRef idx="3">
-            <a:schemeClr val="accent1"/>
-          </a:fillRef>
-          <a:effectRef idx="2">
-            <a:schemeClr val="accent1"/>
-          </a:effectRef>
-          <a:fontRef idx="minor">
-            <a:schemeClr val="lt1"/>
-          </a:fontRef>
-        </p:style>
-        <p:txBody>
-          <a:bodyPr rtlCol="0" anchor="ctr"/>
-          <a:lstStyle/>
-          <a:p>
-            <a:pPr algn="ctr"/>
-          </a:p>
-        </p:txBody>
-      </p:sp>
-      <p:sp>
-        <p:nvSpPr>
-          <p:cNvPr id="40" name="TextBox 39"/>
-          <p:cNvSpPr txBox="1"/>
-          <p:nvPr/>
-        </p:nvSpPr>
-        <p:spPr>
-          <a:xfrm>
-            <a:off x="5157215" y="4882896"/>
-            <a:ext cx="1865376" cy="859536"/>
-          </a:xfrm>
-          <a:prstGeom prst="rect">
-            <a:avLst/>
-          </a:prstGeom>
-          <a:noFill/>
-        </p:spPr>
-        <p:txBody>
-          <a:bodyPr wrap="square" anchor="t" lIns="0" rIns="0" tIns="0" bIns="0">
-            <a:spAutoFit/>
-          </a:bodyPr>
-          <a:lstStyle/>
-          <a:p>
-            <a:pPr algn="l">
-              <a:spcAft>
-                <a:spcPts val="200"/>
-              </a:spcAft>
-            </a:pPr>
-            <a:r>
-              <a:rPr sz="1000" b="1">
-                <a:solidFill>
-                  <a:srgbClr val="1B2A41"/>
-                </a:solidFill>
-                <a:latin typeface="Segoe UI"/>
-              </a:rPr>
-              <a:t>Data Dictionary</a:t>
-            </a:r>
-          </a:p>
-          <a:p>
-            <a:pPr algn="l">
-              <a:spcAft>
-                <a:spcPts val="200"/>
-              </a:spcAft>
-            </a:pPr>
-            <a:r>
-              <a:rPr sz="800" b="0">
-                <a:solidFill>
-                  <a:srgbClr val="40444B"/>
-                </a:solidFill>
-                <a:latin typeface="Segoe UI"/>
-              </a:rPr>
-              <a:t>What lives in ELK — every index and its function</a:t>
-            </a:r>
-          </a:p>
-        </p:txBody>
-      </p:sp>
-      <p:sp>
-        <p:nvSpPr>
-          <p:cNvPr id="41" name="TextBox 40"/>
-          <p:cNvSpPr txBox="1"/>
-          <p:nvPr/>
-        </p:nvSpPr>
-        <p:spPr>
-          <a:xfrm>
-            <a:off x="7269479" y="1810512"/>
-            <a:ext cx="2121408" cy="237744"/>
-          </a:xfrm>
-          <a:prstGeom prst="rect">
-            <a:avLst/>
-          </a:prstGeom>
-          <a:noFill/>
-        </p:spPr>
-        <p:txBody>
-          <a:bodyPr wrap="square" anchor="t" lIns="0" rIns="0" tIns="0" bIns="0">
-            <a:spAutoFit/>
-          </a:bodyPr>
-          <a:lstStyle/>
-          <a:p>
-            <a:pPr algn="l">
-              <a:spcAft>
-                <a:spcPts val="400"/>
-              </a:spcAft>
-            </a:pPr>
-            <a:r>
-              <a:rPr sz="1100" b="1">
-                <a:solidFill>
-                  <a:srgbClr val="2E74B5"/>
-                </a:solidFill>
-                <a:latin typeface="Segoe UI"/>
-              </a:rPr>
-              <a:t>Q2 2027</a:t>
-            </a:r>
-          </a:p>
-        </p:txBody>
-      </p:sp>
-      <p:sp>
-        <p:nvSpPr>
-          <p:cNvPr id="42" name="TextBox 41"/>
-          <p:cNvSpPr txBox="1"/>
-          <p:nvPr/>
-        </p:nvSpPr>
-        <p:spPr>
-          <a:xfrm>
-            <a:off x="7269479" y="2029968"/>
-            <a:ext cx="2121408" cy="182880"/>
-          </a:xfrm>
-          <a:prstGeom prst="rect">
-            <a:avLst/>
-          </a:prstGeom>
-          <a:noFill/>
-        </p:spPr>
-        <p:txBody>
-          <a:bodyPr wrap="square" anchor="t" lIns="0" rIns="0" tIns="0" bIns="0">
-            <a:spAutoFit/>
-          </a:bodyPr>
-          <a:lstStyle/>
-          <a:p>
-            <a:pPr algn="l">
-              <a:spcAft>
-                <a:spcPts val="400"/>
-              </a:spcAft>
-            </a:pPr>
-            <a:r>
-              <a:rPr sz="800" b="1">
-                <a:solidFill>
-                  <a:srgbClr val="7A808A"/>
-                </a:solidFill>
-                <a:latin typeface="Segoe UI"/>
-              </a:rPr>
-              <a:t>ASSURANCE</a:t>
-            </a:r>
-          </a:p>
-        </p:txBody>
-      </p:sp>
-      <p:sp>
-        <p:nvSpPr>
-          <p:cNvPr id="43" name="Rectangle 42"/>
-          <p:cNvSpPr/>
-          <p:nvPr/>
-        </p:nvSpPr>
-        <p:spPr>
-          <a:xfrm>
-            <a:off x="7269479" y="2212848"/>
-            <a:ext cx="457200" cy="25603"/>
-          </a:xfrm>
-          <a:prstGeom prst="rect">
-            <a:avLst/>
-          </a:prstGeom>
-          <a:solidFill>
-            <a:srgbClr val="2E74B5"/>
-          </a:solidFill>
-          <a:ln>
-            <a:noFill/>
-          </a:ln>
-          <a:effectLst/>
-        </p:spPr>
-        <p:style>
-          <a:lnRef idx="1">
-            <a:schemeClr val="accent1"/>
-          </a:lnRef>
-          <a:fillRef idx="3">
-            <a:schemeClr val="accent1"/>
-          </a:fillRef>
-          <a:effectRef idx="2">
-            <a:schemeClr val="accent1"/>
-          </a:effectRef>
-          <a:fontRef idx="minor">
-            <a:schemeClr val="lt1"/>
-          </a:fontRef>
-        </p:style>
-        <p:txBody>
-          <a:bodyPr rtlCol="0" anchor="ctr"/>
-          <a:lstStyle/>
-          <a:p>
-            <a:pPr algn="ctr"/>
-          </a:p>
-        </p:txBody>
-      </p:sp>
-      <p:sp>
-        <p:nvSpPr>
-          <p:cNvPr id="44" name="Rectangle 43"/>
-          <p:cNvSpPr/>
-          <p:nvPr/>
-        </p:nvSpPr>
-        <p:spPr>
-          <a:xfrm>
-            <a:off x="7269479" y="2395728"/>
-            <a:ext cx="2121408" cy="1060704"/>
-          </a:xfrm>
-          <a:prstGeom prst="rect">
-            <a:avLst/>
-          </a:prstGeom>
-          <a:solidFill>
-            <a:srgbClr val="FFFFFF"/>
-          </a:solidFill>
-          <a:ln w="9525">
-            <a:solidFill>
-              <a:srgbClr val="D8DCE1"/>
-            </a:solidFill>
-          </a:ln>
-          <a:effectLst/>
-        </p:spPr>
-        <p:style>
-          <a:lnRef idx="1">
-            <a:schemeClr val="accent1"/>
-          </a:lnRef>
-          <a:fillRef idx="3">
-            <a:schemeClr val="accent1"/>
-          </a:fillRef>
-          <a:effectRef idx="2">
-            <a:schemeClr val="accent1"/>
-          </a:effectRef>
-          <a:fontRef idx="minor">
-            <a:schemeClr val="lt1"/>
-          </a:fontRef>
-        </p:style>
-        <p:txBody>
-          <a:bodyPr rtlCol="0" anchor="ctr"/>
-          <a:lstStyle/>
-          <a:p>
-            <a:pPr algn="ctr"/>
-          </a:p>
-        </p:txBody>
-      </p:sp>
-      <p:sp>
-        <p:nvSpPr>
-          <p:cNvPr id="45" name="Rectangle 44"/>
-          <p:cNvSpPr/>
-          <p:nvPr/>
-        </p:nvSpPr>
-        <p:spPr>
-          <a:xfrm>
-            <a:off x="7269479" y="2395728"/>
-            <a:ext cx="2121408" cy="36576"/>
-          </a:xfrm>
-          <a:prstGeom prst="rect">
-            <a:avLst/>
-          </a:prstGeom>
-          <a:solidFill>
-            <a:srgbClr val="2E74B5"/>
-          </a:solidFill>
-          <a:ln>
-            <a:noFill/>
-          </a:ln>
-          <a:effectLst/>
-        </p:spPr>
-        <p:style>
-          <a:lnRef idx="1">
-            <a:schemeClr val="accent1"/>
-          </a:lnRef>
-          <a:fillRef idx="3">
-            <a:schemeClr val="accent1"/>
-          </a:fillRef>
-          <a:effectRef idx="2">
-            <a:schemeClr val="accent1"/>
-          </a:effectRef>
-          <a:fontRef idx="minor">
-            <a:schemeClr val="lt1"/>
-          </a:fontRef>
-        </p:style>
-        <p:txBody>
-          <a:bodyPr rtlCol="0" anchor="ctr"/>
-          <a:lstStyle/>
-          <a:p>
-            <a:pPr algn="ctr"/>
-          </a:p>
-        </p:txBody>
-      </p:sp>
-      <p:sp>
-        <p:nvSpPr>
-          <p:cNvPr id="46" name="TextBox 45"/>
-          <p:cNvSpPr txBox="1"/>
-          <p:nvPr/>
-        </p:nvSpPr>
-        <p:spPr>
-          <a:xfrm>
-            <a:off x="7397496" y="2505456"/>
-            <a:ext cx="1865376" cy="859536"/>
-          </a:xfrm>
-          <a:prstGeom prst="rect">
-            <a:avLst/>
-          </a:prstGeom>
-          <a:noFill/>
-        </p:spPr>
-        <p:txBody>
-          <a:bodyPr wrap="square" anchor="t" lIns="0" rIns="0" tIns="0" bIns="0">
-            <a:spAutoFit/>
-          </a:bodyPr>
-          <a:lstStyle/>
-          <a:p>
-            <a:pPr algn="l">
-              <a:spcAft>
-                <a:spcPts val="200"/>
-              </a:spcAft>
-            </a:pPr>
-            <a:r>
-              <a:rPr sz="1000" b="1">
-                <a:solidFill>
-                  <a:srgbClr val="1B2A41"/>
-                </a:solidFill>
-                <a:latin typeface="Segoe UI"/>
-              </a:rPr>
-              <a:t>Observability Score</a:t>
-            </a:r>
-          </a:p>
-          <a:p>
-            <a:pPr algn="l">
-              <a:spcAft>
-                <a:spcPts val="200"/>
-              </a:spcAft>
-            </a:pPr>
-            <a:r>
-              <a:rPr sz="800" b="0">
-                <a:solidFill>
-                  <a:srgbClr val="40444B"/>
-                </a:solidFill>
-                <a:latin typeface="Segoe UI"/>
-              </a:rPr>
-              <a:t>Scorecard and certification level per asset, with remediation</a:t>
-            </a:r>
-          </a:p>
-        </p:txBody>
-      </p:sp>
-      <p:sp>
-        <p:nvSpPr>
-          <p:cNvPr id="47" name="Rectangle 46"/>
-          <p:cNvSpPr/>
-          <p:nvPr/>
-        </p:nvSpPr>
-        <p:spPr>
-          <a:xfrm>
-            <a:off x="7269479" y="3584448"/>
-            <a:ext cx="2121408" cy="1060704"/>
-          </a:xfrm>
-          <a:prstGeom prst="rect">
-            <a:avLst/>
-          </a:prstGeom>
-          <a:solidFill>
-            <a:srgbClr val="FFFFFF"/>
-          </a:solidFill>
-          <a:ln w="9525">
-            <a:solidFill>
-              <a:srgbClr val="D8DCE1"/>
-            </a:solidFill>
-          </a:ln>
-          <a:effectLst/>
-        </p:spPr>
-        <p:style>
-          <a:lnRef idx="1">
-            <a:schemeClr val="accent1"/>
-          </a:lnRef>
-          <a:fillRef idx="3">
-            <a:schemeClr val="accent1"/>
-          </a:fillRef>
-          <a:effectRef idx="2">
-            <a:schemeClr val="accent1"/>
-          </a:effectRef>
-          <a:fontRef idx="minor">
-            <a:schemeClr val="lt1"/>
-          </a:fontRef>
-        </p:style>
-        <p:txBody>
-          <a:bodyPr rtlCol="0" anchor="ctr"/>
-          <a:lstStyle/>
-          <a:p>
-            <a:pPr algn="ctr"/>
-          </a:p>
-        </p:txBody>
-      </p:sp>
-      <p:sp>
-        <p:nvSpPr>
-          <p:cNvPr id="48" name="Rectangle 47"/>
-          <p:cNvSpPr/>
-          <p:nvPr/>
-        </p:nvSpPr>
-        <p:spPr>
-          <a:xfrm>
-            <a:off x="7269479" y="3584448"/>
-            <a:ext cx="2121408" cy="36576"/>
-          </a:xfrm>
-          <a:prstGeom prst="rect">
-            <a:avLst/>
-          </a:prstGeom>
-          <a:solidFill>
-            <a:srgbClr val="2E74B5"/>
-          </a:solidFill>
-          <a:ln>
-            <a:noFill/>
-          </a:ln>
-          <a:effectLst/>
-        </p:spPr>
-        <p:style>
-          <a:lnRef idx="1">
-            <a:schemeClr val="accent1"/>
-          </a:lnRef>
-          <a:fillRef idx="3">
-            <a:schemeClr val="accent1"/>
-          </a:fillRef>
-          <a:effectRef idx="2">
-            <a:schemeClr val="accent1"/>
-          </a:effectRef>
-          <a:fontRef idx="minor">
-            <a:schemeClr val="lt1"/>
-          </a:fontRef>
-        </p:style>
-        <p:txBody>
-          <a:bodyPr rtlCol="0" anchor="ctr"/>
-          <a:lstStyle/>
-          <a:p>
-            <a:pPr algn="ctr"/>
-          </a:p>
-        </p:txBody>
-      </p:sp>
-      <p:sp>
-        <p:nvSpPr>
-          <p:cNvPr id="49" name="TextBox 48"/>
-          <p:cNvSpPr txBox="1"/>
-          <p:nvPr/>
-        </p:nvSpPr>
-        <p:spPr>
-          <a:xfrm>
-            <a:off x="7397496" y="3694176"/>
-            <a:ext cx="1865376" cy="859536"/>
-          </a:xfrm>
-          <a:prstGeom prst="rect">
-            <a:avLst/>
-          </a:prstGeom>
-          <a:noFill/>
-        </p:spPr>
-        <p:txBody>
-          <a:bodyPr wrap="square" anchor="t" lIns="0" rIns="0" tIns="0" bIns="0">
-            <a:spAutoFit/>
-          </a:bodyPr>
-          <a:lstStyle/>
-          <a:p>
-            <a:pPr algn="l">
-              <a:spcAft>
-                <a:spcPts val="200"/>
-              </a:spcAft>
-            </a:pPr>
-            <a:r>
-              <a:rPr sz="1000" b="1">
-                <a:solidFill>
-                  <a:srgbClr val="1B2A41"/>
-                </a:solidFill>
-                <a:latin typeface="Segoe UI"/>
-              </a:rPr>
-              <a:t>Synthetic Alerting</a:t>
-            </a:r>
-          </a:p>
-          <a:p>
-            <a:pPr algn="l">
-              <a:spcAft>
-                <a:spcPts val="200"/>
-              </a:spcAft>
-            </a:pPr>
-            <a:r>
-              <a:rPr sz="800" b="0">
-                <a:solidFill>
-                  <a:srgbClr val="40444B"/>
-                </a:solidFill>
-                <a:latin typeface="Segoe UI"/>
-              </a:rPr>
-              <a:t>Fire-drill an alert end to end — [DRILL] ticket out</a:t>
-            </a:r>
-          </a:p>
-        </p:txBody>
-      </p:sp>
-      <p:sp>
-        <p:nvSpPr>
-          <p:cNvPr id="50" name="Rectangle 49"/>
-          <p:cNvSpPr/>
-          <p:nvPr/>
-        </p:nvSpPr>
-        <p:spPr>
-          <a:xfrm>
-            <a:off x="7269479" y="4773168"/>
-            <a:ext cx="2121408" cy="1060704"/>
-          </a:xfrm>
-          <a:prstGeom prst="rect">
-            <a:avLst/>
-          </a:prstGeom>
-          <a:solidFill>
-            <a:srgbClr val="FFFFFF"/>
-          </a:solidFill>
-          <a:ln w="9525">
-            <a:solidFill>
-              <a:srgbClr val="D8DCE1"/>
-            </a:solidFill>
-          </a:ln>
-          <a:effectLst/>
-        </p:spPr>
-        <p:style>
-          <a:lnRef idx="1">
-            <a:schemeClr val="accent1"/>
-          </a:lnRef>
-          <a:fillRef idx="3">
-            <a:schemeClr val="accent1"/>
-          </a:fillRef>
-          <a:effectRef idx="2">
-            <a:schemeClr val="accent1"/>
-          </a:effectRef>
-          <a:fontRef idx="minor">
-            <a:schemeClr val="lt1"/>
-          </a:fontRef>
-        </p:style>
-        <p:txBody>
-          <a:bodyPr rtlCol="0" anchor="ctr"/>
-          <a:lstStyle/>
-          <a:p>
-            <a:pPr algn="ctr"/>
-          </a:p>
-        </p:txBody>
-      </p:sp>
-      <p:sp>
-        <p:nvSpPr>
-          <p:cNvPr id="51" name="Rectangle 50"/>
-          <p:cNvSpPr/>
-          <p:nvPr/>
-        </p:nvSpPr>
-        <p:spPr>
-          <a:xfrm>
-            <a:off x="7269479" y="4773168"/>
-            <a:ext cx="2121408" cy="36576"/>
-          </a:xfrm>
-          <a:prstGeom prst="rect">
-            <a:avLst/>
-          </a:prstGeom>
-          <a:solidFill>
-            <a:srgbClr val="2E74B5"/>
-          </a:solidFill>
-          <a:ln>
-            <a:noFill/>
-          </a:ln>
-          <a:effectLst/>
-        </p:spPr>
-        <p:style>
-          <a:lnRef idx="1">
-            <a:schemeClr val="accent1"/>
-          </a:lnRef>
-          <a:fillRef idx="3">
-            <a:schemeClr val="accent1"/>
-          </a:fillRef>
-          <a:effectRef idx="2">
-            <a:schemeClr val="accent1"/>
-          </a:effectRef>
-          <a:fontRef idx="minor">
-            <a:schemeClr val="lt1"/>
-          </a:fontRef>
-        </p:style>
-        <p:txBody>
-          <a:bodyPr rtlCol="0" anchor="ctr"/>
-          <a:lstStyle/>
-          <a:p>
-            <a:pPr algn="ctr"/>
-          </a:p>
-        </p:txBody>
-      </p:sp>
-      <p:sp>
-        <p:nvSpPr>
-          <p:cNvPr id="52" name="TextBox 51"/>
-          <p:cNvSpPr txBox="1"/>
-          <p:nvPr/>
-        </p:nvSpPr>
-        <p:spPr>
-          <a:xfrm>
-            <a:off x="7397496" y="4882896"/>
-            <a:ext cx="1865376" cy="859536"/>
-          </a:xfrm>
-          <a:prstGeom prst="rect">
-            <a:avLst/>
-          </a:prstGeom>
-          <a:noFill/>
-        </p:spPr>
-        <p:txBody>
-          <a:bodyPr wrap="square" anchor="t" lIns="0" rIns="0" tIns="0" bIns="0">
-            <a:spAutoFit/>
-          </a:bodyPr>
-          <a:lstStyle/>
-          <a:p>
-            <a:pPr algn="l">
-              <a:spcAft>
-                <a:spcPts val="200"/>
-              </a:spcAft>
-            </a:pPr>
-            <a:r>
-              <a:rPr sz="1000" b="1">
-                <a:solidFill>
-                  <a:srgbClr val="1B2A41"/>
-                </a:solidFill>
-                <a:latin typeface="Segoe UI"/>
-              </a:rPr>
-              <a:t>Alert Suppression</a:t>
-            </a:r>
-          </a:p>
-          <a:p>
-            <a:pPr algn="l">
-              <a:spcAft>
-                <a:spcPts val="200"/>
-              </a:spcAft>
-            </a:pPr>
-            <a:r>
-              <a:rPr sz="800" b="0">
-                <a:solidFill>
-                  <a:srgbClr val="40444B"/>
-                </a:solidFill>
-                <a:latin typeface="Segoe UI"/>
-              </a:rPr>
-              <a:t>Governed change windows — approved, recorded, auto-expiring</a:t>
-            </a:r>
-          </a:p>
-        </p:txBody>
-      </p:sp>
-      <p:sp>
-        <p:nvSpPr>
-          <p:cNvPr id="53" name="TextBox 52"/>
-          <p:cNvSpPr txBox="1"/>
-          <p:nvPr/>
-        </p:nvSpPr>
-        <p:spPr>
-          <a:xfrm>
-            <a:off x="9509759" y="1810512"/>
-            <a:ext cx="2121408" cy="237744"/>
-          </a:xfrm>
-          <a:prstGeom prst="rect">
-            <a:avLst/>
-          </a:prstGeom>
-          <a:noFill/>
-        </p:spPr>
-        <p:txBody>
-          <a:bodyPr wrap="square" anchor="t" lIns="0" rIns="0" tIns="0" bIns="0">
-            <a:spAutoFit/>
-          </a:bodyPr>
-          <a:lstStyle/>
-          <a:p>
-            <a:pPr algn="l">
-              <a:spcAft>
-                <a:spcPts val="400"/>
-              </a:spcAft>
-            </a:pPr>
-            <a:r>
-              <a:rPr sz="1100" b="1">
-                <a:solidFill>
-                  <a:srgbClr val="2E74B5"/>
-                </a:solidFill>
-                <a:latin typeface="Segoe UI"/>
-              </a:rPr>
-              <a:t>H2 2027</a:t>
-            </a:r>
-          </a:p>
-        </p:txBody>
-      </p:sp>
-      <p:sp>
-        <p:nvSpPr>
-          <p:cNvPr id="54" name="TextBox 53"/>
-          <p:cNvSpPr txBox="1"/>
-          <p:nvPr/>
-        </p:nvSpPr>
-        <p:spPr>
-          <a:xfrm>
-            <a:off x="9509759" y="2029968"/>
-            <a:ext cx="2121408" cy="182880"/>
-          </a:xfrm>
-          <a:prstGeom prst="rect">
-            <a:avLst/>
-          </a:prstGeom>
-          <a:noFill/>
-        </p:spPr>
-        <p:txBody>
-          <a:bodyPr wrap="square" anchor="t" lIns="0" rIns="0" tIns="0" bIns="0">
-            <a:spAutoFit/>
-          </a:bodyPr>
-          <a:lstStyle/>
-          <a:p>
-            <a:pPr algn="l">
-              <a:spcAft>
-                <a:spcPts val="400"/>
-              </a:spcAft>
-            </a:pPr>
-            <a:r>
-              <a:rPr sz="800" b="1">
-                <a:solidFill>
-                  <a:srgbClr val="7A808A"/>
-                </a:solidFill>
-                <a:latin typeface="Segoe UI"/>
-              </a:rPr>
-              <a:t>INTELLIGENCE</a:t>
-            </a:r>
-          </a:p>
-        </p:txBody>
-      </p:sp>
-      <p:sp>
-        <p:nvSpPr>
-          <p:cNvPr id="55" name="Rectangle 54"/>
-          <p:cNvSpPr/>
-          <p:nvPr/>
-        </p:nvSpPr>
-        <p:spPr>
-          <a:xfrm>
-            <a:off x="9509759" y="2212848"/>
-            <a:ext cx="457200" cy="25603"/>
-          </a:xfrm>
-          <a:prstGeom prst="rect">
-            <a:avLst/>
-          </a:prstGeom>
-          <a:solidFill>
-            <a:srgbClr val="2E74B5"/>
-          </a:solidFill>
-          <a:ln>
-            <a:noFill/>
-          </a:ln>
-          <a:effectLst/>
-        </p:spPr>
-        <p:style>
-          <a:lnRef idx="1">
-            <a:schemeClr val="accent1"/>
-          </a:lnRef>
-          <a:fillRef idx="3">
-            <a:schemeClr val="accent1"/>
-          </a:fillRef>
-          <a:effectRef idx="2">
-            <a:schemeClr val="accent1"/>
-          </a:effectRef>
-          <a:fontRef idx="minor">
-            <a:schemeClr val="lt1"/>
-          </a:fontRef>
-        </p:style>
-        <p:txBody>
-          <a:bodyPr rtlCol="0" anchor="ctr"/>
-          <a:lstStyle/>
-          <a:p>
-            <a:pPr algn="ctr"/>
-          </a:p>
-        </p:txBody>
-      </p:sp>
-      <p:sp>
-        <p:nvSpPr>
-          <p:cNvPr id="56" name="Rectangle 55"/>
-          <p:cNvSpPr/>
-          <p:nvPr/>
-        </p:nvSpPr>
-        <p:spPr>
-          <a:xfrm>
-            <a:off x="9509759" y="2395728"/>
-            <a:ext cx="2121408" cy="1060704"/>
-          </a:xfrm>
-          <a:prstGeom prst="rect">
-            <a:avLst/>
-          </a:prstGeom>
-          <a:solidFill>
-            <a:srgbClr val="1B2A41"/>
-          </a:solidFill>
-          <a:ln>
-            <a:noFill/>
-          </a:ln>
-          <a:effectLst/>
-        </p:spPr>
-        <p:style>
-          <a:lnRef idx="1">
-            <a:schemeClr val="accent1"/>
-          </a:lnRef>
-          <a:fillRef idx="3">
-            <a:schemeClr val="accent1"/>
-          </a:fillRef>
-          <a:effectRef idx="2">
-            <a:schemeClr val="accent1"/>
-          </a:effectRef>
-          <a:fontRef idx="minor">
-            <a:schemeClr val="lt1"/>
-          </a:fontRef>
-        </p:style>
-        <p:txBody>
-          <a:bodyPr rtlCol="0" anchor="ctr"/>
-          <a:lstStyle/>
-          <a:p>
-            <a:pPr algn="ctr"/>
-          </a:p>
-        </p:txBody>
-      </p:sp>
-      <p:sp>
-        <p:nvSpPr>
-          <p:cNvPr id="57" name="TextBox 56"/>
-          <p:cNvSpPr txBox="1"/>
-          <p:nvPr/>
-        </p:nvSpPr>
-        <p:spPr>
-          <a:xfrm>
-            <a:off x="9637776" y="2505456"/>
-            <a:ext cx="1865376" cy="859536"/>
-          </a:xfrm>
-          <a:prstGeom prst="rect">
-            <a:avLst/>
-          </a:prstGeom>
-          <a:noFill/>
-        </p:spPr>
-        <p:txBody>
-          <a:bodyPr wrap="square" anchor="t" lIns="0" rIns="0" tIns="0" bIns="0">
-            <a:spAutoFit/>
-          </a:bodyPr>
-          <a:lstStyle/>
-          <a:p>
-            <a:pPr algn="l">
-              <a:spcAft>
-                <a:spcPts val="200"/>
-              </a:spcAft>
-            </a:pPr>
-            <a:r>
-              <a:rPr sz="1000" b="1">
-                <a:solidFill>
-                  <a:srgbClr val="FFFFFF"/>
-                </a:solidFill>
-                <a:latin typeface="Segoe UI"/>
-              </a:rPr>
-              <a:t>Observability Brain</a:t>
-            </a:r>
-          </a:p>
-          <a:p>
-            <a:pPr algn="l">
-              <a:spcAft>
-                <a:spcPts val="200"/>
-              </a:spcAft>
-            </a:pPr>
-            <a:r>
-              <a:rPr sz="800" b="0">
-                <a:solidFill>
-                  <a:srgbClr val="C9D2DD"/>
-                </a:solidFill>
-                <a:latin typeface="Segoe UI"/>
-              </a:rPr>
-              <a:t>The oracle at the front door — grounded, cited answers over the second brain</a:t>
-            </a:r>
-          </a:p>
-        </p:txBody>
-      </p:sp>
-      <p:sp>
-        <p:nvSpPr>
-          <p:cNvPr id="58" name="TextBox 57"/>
-          <p:cNvSpPr txBox="1"/>
-          <p:nvPr/>
-        </p:nvSpPr>
-        <p:spPr>
-          <a:xfrm>
-            <a:off x="548640" y="6035040"/>
-            <a:ext cx="11064240" cy="365760"/>
-          </a:xfrm>
-          <a:prstGeom prst="rect">
-            <a:avLst/>
-          </a:prstGeom>
-          <a:noFill/>
-        </p:spPr>
-        <p:txBody>
-          <a:bodyPr wrap="square" anchor="t" lIns="0" rIns="0" tIns="0" bIns="0">
-            <a:spAutoFit/>
-          </a:bodyPr>
-          <a:lstStyle/>
-          <a:p>
-            <a:pPr algn="l">
-              <a:spcAft>
-                <a:spcPts val="0"/>
-              </a:spcAft>
-            </a:pPr>
-            <a:r>
-              <a:rPr sz="950" b="1">
-                <a:solidFill>
-                  <a:srgbClr val="1B2A41"/>
-                </a:solidFill>
-                <a:latin typeface="Segoe UI"/>
-              </a:rPr>
-              <a:t>Why this order: </a:t>
-            </a:r>
-            <a:r>
-              <a:rPr sz="900" b="0">
-                <a:solidFill>
-                  <a:srgbClr val="40444B"/>
-                </a:solidFill>
-                <a:latin typeface="Segoe UI"/>
-              </a:rPr>
-              <a:t>harden the live slice first · land the log stack together · visibility needs the reconciliation plumbing · assurance needs assets worth scoring · the Brain reads everything the earlier phases record.</a:t>
-            </a:r>
-          </a:p>
-        </p:txBody>
-      </p:sp>
-      <p:sp>
-        <p:nvSpPr>
-          <p:cNvPr id="59" name="Rectangle 58"/>
+              <a:t>Why this order: harden the live slice → land the log stack together → visibility needs reconciliation → assurance needs assets worth scoring → the Brain reads everything recorded before it.</a:t>
+            </a:r>
+          </a:p>
+        </p:txBody>
+      </p:sp>
+      <p:sp>
+        <p:nvSpPr>
+          <p:cNvPr id="83" name="Rectangle 82"/>
           <p:cNvSpPr/>
           <p:nvPr/>
         </p:nvSpPr>
@@ -14845,7 +15401,7 @@
       </p:sp>
       <p:sp>
         <p:nvSpPr>
-          <p:cNvPr id="60" name="TextBox 59"/>
+          <p:cNvPr id="84" name="TextBox 83"/>
           <p:cNvSpPr txBox="1"/>
           <p:nvPr/>
         </p:nvSpPr>
@@ -14884,7 +15440,7 @@
       </p:sp>
       <p:sp>
         <p:nvSpPr>
-          <p:cNvPr id="61" name="TextBox 60"/>
+          <p:cNvPr id="85" name="TextBox 84"/>
           <p:cNvSpPr txBox="1"/>
           <p:nvPr/>
         </p:nvSpPr>

</xml_diff>